<commit_message>
docs: add HootCamp origin and compressed demo artifacts
Record the NASA challenge lineage for this FAU school project and push a smaller pitch deck and demo video under GitHub size limits.
</commit_message>
<xml_diff>
--- a/docs/final/Space_Biology_Evidence_Engine_Pitch_Deck.pptx
+++ b/docs/final/Space_Biology_Evidence_Engine_Pitch_Deck.pptx
@@ -3561,10 +3561,24 @@
             <a:spLocks noGrp="1" noRot="1" noChangeAspect="1"/>
           </p:cNvSpPr>
           <p:nvPr>
-            <p:ph type="sldImg" idx="2"/>
+            <p:ph type="sldImg"/>
           </p:nvPr>
         </p:nvSpPr>
-        <p:spPr/>
+        <p:spPr>
+          <a:xfrm>
+            <a:off x="685800" y="1143000"/>
+            <a:ext cx="5486400" cy="3086100"/>
+          </a:xfrm>
+          <a:prstGeom prst="rect">
+            <a:avLst/>
+          </a:prstGeom>
+          <a:noFill/>
+          <a:ln w="12700">
+            <a:solidFill>
+              <a:prstClr val="black"/>
+            </a:solidFill>
+          </a:ln>
+        </p:spPr>
       </p:sp>
       <p:sp>
         <p:nvSpPr>
@@ -3573,33 +3587,420 @@
             <a:spLocks noGrp="1"/>
           </p:cNvSpPr>
           <p:nvPr>
-            <p:ph type="body" sz="quarter" idx="3"/>
+            <p:ph type="body" idx="1"/>
           </p:nvPr>
         </p:nvSpPr>
-        <p:spPr/>
+        <p:spPr>
+          <a:xfrm>
+            <a:off x="685800" y="4400550"/>
+            <a:ext cx="5486400" cy="3600450"/>
+          </a:xfrm>
+          <a:prstGeom prst="rect">
+            <a:avLst/>
+          </a:prstGeom>
+        </p:spPr>
         <p:txBody>
           <a:bodyPr/>
           <a:lstStyle/>
           <a:p>
             <a:r>
-              <a:t>Explain that the core problem is not access to a language model. It is evidence discovery with scientific provenance and explicit limits.</a:t>
-            </a:r>
+              <a:rPr lang="en-US" sz="2400" b="0" i="0" kern="1200" dirty="0">
+                <a:solidFill>
+                  <a:schemeClr val="tx1"/>
+                </a:solidFill>
+                <a:effectLst/>
+                <a:latin typeface="+mn-lt"/>
+                <a:ea typeface="+mn-ea"/>
+                <a:cs typeface="+mn-cs"/>
+              </a:rPr>
+              <a:t>Good [afternoon]. </a:t>
+            </a:r>
+          </a:p>
+          <a:p>
+            <a:endParaRPr lang="en-US" sz="2400" b="0" i="0" kern="1200" dirty="0">
+              <a:solidFill>
+                <a:schemeClr val="tx1"/>
+              </a:solidFill>
+              <a:effectLst/>
+              <a:latin typeface="+mn-lt"/>
+              <a:ea typeface="+mn-ea"/>
+              <a:cs typeface="+mn-cs"/>
+            </a:endParaRPr>
+          </a:p>
+          <a:p>
+            <a:r>
+              <a:rPr lang="en-US" sz="2400" b="0" i="0" kern="1200" dirty="0">
+                <a:solidFill>
+                  <a:schemeClr val="tx1"/>
+                </a:solidFill>
+                <a:effectLst/>
+                <a:latin typeface="+mn-lt"/>
+                <a:ea typeface="+mn-ea"/>
+                <a:cs typeface="+mn-cs"/>
+              </a:rPr>
+              <a:t>I’m presenting the Space Biology Evidence Engine, a citation-first research synthesis system for space biology. </a:t>
+            </a:r>
+          </a:p>
+          <a:p>
+            <a:endParaRPr lang="en-US" sz="2400" b="0" i="0" kern="1200" dirty="0">
+              <a:solidFill>
+                <a:schemeClr val="tx1"/>
+              </a:solidFill>
+              <a:effectLst/>
+              <a:latin typeface="+mn-lt"/>
+              <a:ea typeface="+mn-ea"/>
+              <a:cs typeface="+mn-cs"/>
+            </a:endParaRPr>
+          </a:p>
+          <a:p>
+            <a:r>
+              <a:rPr lang="en-US" sz="2400" b="0" i="0" kern="1200" dirty="0">
+                <a:solidFill>
+                  <a:schemeClr val="tx1"/>
+                </a:solidFill>
+                <a:effectLst/>
+                <a:latin typeface="+mn-lt"/>
+                <a:ea typeface="+mn-ea"/>
+                <a:cs typeface="+mn-cs"/>
+              </a:rPr>
+              <a:t>The project was originally based on NASA’s </a:t>
+            </a:r>
+          </a:p>
+          <a:p>
+            <a:r>
+              <a:rPr lang="en-US" sz="2400" b="0" i="0" kern="1200" dirty="0">
+                <a:solidFill>
+                  <a:schemeClr val="tx1"/>
+                </a:solidFill>
+                <a:effectLst/>
+                <a:latin typeface="+mn-lt"/>
+                <a:ea typeface="+mn-ea"/>
+                <a:cs typeface="+mn-cs"/>
+              </a:rPr>
+              <a:t>‘Space Biology Knowledge Engine’ challenge. </a:t>
+            </a:r>
+          </a:p>
+          <a:p>
+            <a:endParaRPr lang="en-US" sz="2400" b="0" i="0" kern="1200" dirty="0">
+              <a:solidFill>
+                <a:schemeClr val="tx1"/>
+              </a:solidFill>
+              <a:effectLst/>
+              <a:latin typeface="+mn-lt"/>
+              <a:ea typeface="+mn-ea"/>
+              <a:cs typeface="+mn-cs"/>
+            </a:endParaRPr>
+          </a:p>
+          <a:p>
+            <a:r>
+              <a:rPr lang="en-US" sz="2400" b="0" i="0" kern="1200" dirty="0">
+                <a:solidFill>
+                  <a:schemeClr val="tx1"/>
+                </a:solidFill>
+                <a:effectLst/>
+                <a:latin typeface="+mn-lt"/>
+                <a:ea typeface="+mn-ea"/>
+                <a:cs typeface="+mn-cs"/>
+              </a:rPr>
+              <a:t>However, </a:t>
+            </a:r>
+          </a:p>
+          <a:p>
+            <a:endParaRPr lang="en-US" sz="2400" b="0" i="0" kern="1200" dirty="0">
+              <a:solidFill>
+                <a:schemeClr val="tx1"/>
+              </a:solidFill>
+              <a:effectLst/>
+              <a:latin typeface="+mn-lt"/>
+              <a:ea typeface="+mn-ea"/>
+              <a:cs typeface="+mn-cs"/>
+            </a:endParaRPr>
+          </a:p>
+          <a:p>
+            <a:r>
+              <a:rPr lang="en-US" sz="2400" b="0" i="0" kern="1200" dirty="0">
+                <a:solidFill>
+                  <a:schemeClr val="tx1"/>
+                </a:solidFill>
+                <a:effectLst/>
+                <a:latin typeface="+mn-lt"/>
+                <a:ea typeface="+mn-ea"/>
+                <a:cs typeface="+mn-cs"/>
+              </a:rPr>
+              <a:t>since the competition had already closed, </a:t>
+            </a:r>
+          </a:p>
+          <a:p>
+            <a:endParaRPr lang="en-US" sz="2400" b="0" i="0" kern="1200" dirty="0">
+              <a:solidFill>
+                <a:schemeClr val="tx1"/>
+              </a:solidFill>
+              <a:effectLst/>
+              <a:latin typeface="+mn-lt"/>
+              <a:ea typeface="+mn-ea"/>
+              <a:cs typeface="+mn-cs"/>
+            </a:endParaRPr>
+          </a:p>
+          <a:p>
+            <a:r>
+              <a:rPr lang="en-US" sz="2400" b="0" i="0" kern="1200" dirty="0">
+                <a:solidFill>
+                  <a:schemeClr val="tx1"/>
+                </a:solidFill>
+                <a:effectLst/>
+                <a:latin typeface="+mn-lt"/>
+                <a:ea typeface="+mn-ea"/>
+                <a:cs typeface="+mn-cs"/>
+              </a:rPr>
+              <a:t>it was decided to continue with a similar </a:t>
+            </a:r>
+          </a:p>
+          <a:p>
+            <a:endParaRPr lang="en-US" sz="2400" b="0" i="0" kern="1200" dirty="0">
+              <a:solidFill>
+                <a:schemeClr val="tx1"/>
+              </a:solidFill>
+              <a:effectLst/>
+              <a:latin typeface="+mn-lt"/>
+              <a:ea typeface="+mn-ea"/>
+              <a:cs typeface="+mn-cs"/>
+            </a:endParaRPr>
+          </a:p>
+          <a:p>
+            <a:r>
+              <a:rPr lang="en-US" sz="2400" b="0" i="0" kern="1200" dirty="0">
+                <a:solidFill>
+                  <a:schemeClr val="tx1"/>
+                </a:solidFill>
+                <a:effectLst/>
+                <a:latin typeface="+mn-lt"/>
+                <a:ea typeface="+mn-ea"/>
+                <a:cs typeface="+mn-cs"/>
+              </a:rPr>
+              <a:t>concept as an independent project, </a:t>
+            </a:r>
+          </a:p>
+          <a:p>
+            <a:endParaRPr lang="en-US" sz="2400" b="0" i="0" kern="1200" dirty="0">
+              <a:solidFill>
+                <a:schemeClr val="tx1"/>
+              </a:solidFill>
+              <a:effectLst/>
+              <a:latin typeface="+mn-lt"/>
+              <a:ea typeface="+mn-ea"/>
+              <a:cs typeface="+mn-cs"/>
+            </a:endParaRPr>
+          </a:p>
+          <a:p>
+            <a:r>
+              <a:rPr lang="en-US" sz="2400" b="0" i="0" kern="1200" dirty="0">
+                <a:solidFill>
+                  <a:schemeClr val="tx1"/>
+                </a:solidFill>
+                <a:effectLst/>
+                <a:latin typeface="+mn-lt"/>
+                <a:ea typeface="+mn-ea"/>
+                <a:cs typeface="+mn-cs"/>
+              </a:rPr>
+              <a:t>with a stronger focus </a:t>
+            </a:r>
+          </a:p>
+          <a:p>
+            <a:endParaRPr lang="en-US" sz="2400" b="0" i="0" kern="1200" dirty="0">
+              <a:solidFill>
+                <a:schemeClr val="tx1"/>
+              </a:solidFill>
+              <a:effectLst/>
+              <a:latin typeface="+mn-lt"/>
+              <a:ea typeface="+mn-ea"/>
+              <a:cs typeface="+mn-cs"/>
+            </a:endParaRPr>
+          </a:p>
+          <a:p>
+            <a:r>
+              <a:rPr lang="en-US" sz="2400" b="0" i="0" kern="1200" dirty="0">
+                <a:solidFill>
+                  <a:schemeClr val="tx1"/>
+                </a:solidFill>
+                <a:effectLst/>
+                <a:latin typeface="+mn-lt"/>
+                <a:ea typeface="+mn-ea"/>
+                <a:cs typeface="+mn-cs"/>
+              </a:rPr>
+              <a:t>on information retrieval, </a:t>
+            </a:r>
+          </a:p>
+          <a:p>
+            <a:r>
+              <a:rPr lang="en-US" sz="2400" b="0" i="0" kern="1200" dirty="0">
+                <a:solidFill>
+                  <a:schemeClr val="tx1"/>
+                </a:solidFill>
+                <a:effectLst/>
+                <a:latin typeface="+mn-lt"/>
+                <a:ea typeface="+mn-ea"/>
+                <a:cs typeface="+mn-cs"/>
+              </a:rPr>
+              <a:t>citations, </a:t>
+            </a:r>
+          </a:p>
+          <a:p>
+            <a:r>
+              <a:rPr lang="en-US" sz="2400" b="0" i="0" kern="1200" dirty="0">
+                <a:solidFill>
+                  <a:schemeClr val="tx1"/>
+                </a:solidFill>
+                <a:effectLst/>
+                <a:latin typeface="+mn-lt"/>
+                <a:ea typeface="+mn-ea"/>
+                <a:cs typeface="+mn-cs"/>
+              </a:rPr>
+              <a:t>traceability, </a:t>
+            </a:r>
+          </a:p>
+          <a:p>
+            <a:r>
+              <a:rPr lang="en-US" sz="2400" b="0" i="0" kern="1200" dirty="0">
+                <a:solidFill>
+                  <a:schemeClr val="tx1"/>
+                </a:solidFill>
+                <a:effectLst/>
+                <a:latin typeface="+mn-lt"/>
+                <a:ea typeface="+mn-ea"/>
+                <a:cs typeface="+mn-cs"/>
+              </a:rPr>
+              <a:t>and answering scientific questions</a:t>
+            </a:r>
+          </a:p>
+          <a:p>
+            <a:r>
+              <a:rPr lang="en-US" sz="2400" b="0" i="0" kern="1200" dirty="0">
+                <a:solidFill>
+                  <a:schemeClr val="tx1"/>
+                </a:solidFill>
+                <a:effectLst/>
+                <a:latin typeface="+mn-lt"/>
+                <a:ea typeface="+mn-ea"/>
+                <a:cs typeface="+mn-cs"/>
+              </a:rPr>
+              <a:t> directly from source material. </a:t>
+            </a:r>
+          </a:p>
+          <a:p>
+            <a:endParaRPr lang="en-US" sz="2400" b="0" i="0" kern="1200" dirty="0">
+              <a:solidFill>
+                <a:schemeClr val="tx1"/>
+              </a:solidFill>
+              <a:effectLst/>
+              <a:latin typeface="+mn-lt"/>
+              <a:ea typeface="+mn-ea"/>
+              <a:cs typeface="+mn-cs"/>
+            </a:endParaRPr>
+          </a:p>
+          <a:p>
+            <a:r>
+              <a:rPr lang="en-US" sz="2400" b="0" i="0" kern="1200" dirty="0">
+                <a:solidFill>
+                  <a:schemeClr val="tx1"/>
+                </a:solidFill>
+                <a:effectLst/>
+                <a:latin typeface="+mn-lt"/>
+                <a:ea typeface="+mn-ea"/>
+                <a:cs typeface="+mn-cs"/>
+              </a:rPr>
+              <a:t>The name ‘Space Biology Evidence Engine’ </a:t>
+            </a:r>
+          </a:p>
+          <a:p>
+            <a:r>
+              <a:rPr lang="en-US" sz="2400" b="0" i="0" kern="1200" dirty="0">
+                <a:solidFill>
+                  <a:schemeClr val="tx1"/>
+                </a:solidFill>
+                <a:effectLst/>
+                <a:latin typeface="+mn-lt"/>
+                <a:ea typeface="+mn-ea"/>
+                <a:cs typeface="+mn-cs"/>
+              </a:rPr>
+              <a:t>wa</a:t>
+            </a:r>
+            <a:r>
+              <a:rPr lang="en-US" sz="1200" b="0" i="0" kern="1200" dirty="0">
+                <a:solidFill>
+                  <a:schemeClr val="tx1"/>
+                </a:solidFill>
+                <a:effectLst/>
+                <a:latin typeface="+mn-lt"/>
+                <a:ea typeface="+mn-ea"/>
+                <a:cs typeface="+mn-cs"/>
+              </a:rPr>
+              <a:t>s chosen </a:t>
+            </a:r>
+          </a:p>
+          <a:p>
+            <a:r>
+              <a:rPr lang="en-US" sz="1200" b="0" i="0" kern="1200" dirty="0">
+                <a:solidFill>
+                  <a:schemeClr val="tx1"/>
+                </a:solidFill>
+                <a:effectLst/>
+                <a:latin typeface="+mn-lt"/>
+                <a:ea typeface="+mn-ea"/>
+                <a:cs typeface="+mn-cs"/>
+              </a:rPr>
+              <a:t>because the word ‘Evidence’ </a:t>
+            </a:r>
+          </a:p>
+          <a:p>
+            <a:r>
+              <a:rPr lang="en-US" sz="1200" b="0" i="0" kern="1200" dirty="0">
+                <a:solidFill>
+                  <a:schemeClr val="tx1"/>
+                </a:solidFill>
+                <a:effectLst/>
+                <a:latin typeface="+mn-lt"/>
+                <a:ea typeface="+mn-ea"/>
+                <a:cs typeface="+mn-cs"/>
+              </a:rPr>
+              <a:t>better represents this emphasis </a:t>
+            </a:r>
+          </a:p>
+          <a:p>
+            <a:r>
+              <a:rPr lang="en-US" sz="1200" b="0" i="0" kern="1200" dirty="0">
+                <a:solidFill>
+                  <a:schemeClr val="tx1"/>
+                </a:solidFill>
+                <a:effectLst/>
+                <a:latin typeface="+mn-lt"/>
+                <a:ea typeface="+mn-ea"/>
+                <a:cs typeface="+mn-cs"/>
+              </a:rPr>
+              <a:t>than the broader term ‘Knowledge.’</a:t>
+            </a:r>
+          </a:p>
+          <a:p>
+            <a:endParaRPr lang="en-US" sz="1200" b="0" i="0" kern="1200" dirty="0">
+              <a:solidFill>
+                <a:schemeClr val="tx1"/>
+              </a:solidFill>
+              <a:effectLst/>
+              <a:latin typeface="+mn-lt"/>
+              <a:ea typeface="+mn-ea"/>
+              <a:cs typeface="+mn-cs"/>
+            </a:endParaRPr>
+          </a:p>
+          <a:p>
+            <a:endParaRPr lang="en-US" dirty="0"/>
           </a:p>
         </p:txBody>
       </p:sp>
-      <p:sp>
-        <p:nvSpPr>
-          <p:cNvPr id="4" name="Slide Number Placeholder 3"/>
-          <p:cNvSpPr>
-            <a:spLocks noGrp="1"/>
-          </p:cNvSpPr>
-          <p:nvPr>
-            <p:ph type="sldNum" sz="quarter" idx="5"/>
-          </p:nvPr>
-        </p:nvSpPr>
-        <p:spPr/>
-      </p:sp>
     </p:spTree>
+    <p:extLst>
+      <p:ext uri="{BB962C8B-B14F-4D97-AF65-F5344CB8AC3E}">
+        <p14:creationId xmlns:p14="http://schemas.microsoft.com/office/powerpoint/2010/main" val="831333922"/>
+      </p:ext>
+    </p:extLst>
   </p:cSld>
   <p:clrMapOvr>
     <a:masterClrMapping/>
@@ -3652,8 +4053,137 @@
           <a:lstStyle/>
           <a:p>
             <a:r>
-              <a:t>Be candid about limitations. Emphasize that local-first deployment and a controlled topic were conscious scope decisions, not hidden gaps.</a:t>
-            </a:r>
+              <a:rPr lang="en-US" sz="1200" b="0" i="0" kern="1200" dirty="0">
+                <a:solidFill>
+                  <a:schemeClr val="tx1"/>
+                </a:solidFill>
+                <a:effectLst/>
+                <a:latin typeface="+mn-lt"/>
+                <a:ea typeface="+mn-ea"/>
+                <a:cs typeface="+mn-cs"/>
+              </a:rPr>
+              <a:t>This slide explains the live-demo sequence and backup plan: </a:t>
+            </a:r>
+          </a:p>
+          <a:p>
+            <a:endParaRPr lang="en-US" sz="1200" b="0" i="0" kern="1200" dirty="0">
+              <a:solidFill>
+                <a:schemeClr val="tx1"/>
+              </a:solidFill>
+              <a:effectLst/>
+              <a:latin typeface="+mn-lt"/>
+              <a:ea typeface="+mn-ea"/>
+              <a:cs typeface="+mn-cs"/>
+            </a:endParaRPr>
+          </a:p>
+          <a:p>
+            <a:r>
+              <a:rPr lang="en-US" sz="1200" b="0" i="0" kern="1200" dirty="0">
+                <a:solidFill>
+                  <a:schemeClr val="tx1"/>
+                </a:solidFill>
+                <a:effectLst/>
+                <a:latin typeface="+mn-lt"/>
+                <a:ea typeface="+mn-ea"/>
+                <a:cs typeface="+mn-cs"/>
+              </a:rPr>
+              <a:t>the application can be started locally </a:t>
+            </a:r>
+            <a:br>
+              <a:rPr lang="en-US" sz="1200" b="0" i="0" kern="1200" dirty="0">
+                <a:solidFill>
+                  <a:schemeClr val="tx1"/>
+                </a:solidFill>
+                <a:effectLst/>
+                <a:latin typeface="+mn-lt"/>
+                <a:ea typeface="+mn-ea"/>
+                <a:cs typeface="+mn-cs"/>
+              </a:rPr>
+            </a:br>
+            <a:r>
+              <a:rPr lang="en-US" sz="1200" b="0" i="0" kern="1200" dirty="0">
+                <a:solidFill>
+                  <a:schemeClr val="tx1"/>
+                </a:solidFill>
+                <a:effectLst/>
+                <a:latin typeface="+mn-lt"/>
+                <a:ea typeface="+mn-ea"/>
+                <a:cs typeface="+mn-cs"/>
+              </a:rPr>
+              <a:t>with Docker Compose, </a:t>
+            </a:r>
+          </a:p>
+          <a:p>
+            <a:endParaRPr lang="en-US" sz="1200" b="0" i="0" kern="1200" dirty="0">
+              <a:solidFill>
+                <a:schemeClr val="tx1"/>
+              </a:solidFill>
+              <a:effectLst/>
+              <a:latin typeface="+mn-lt"/>
+              <a:ea typeface="+mn-ea"/>
+              <a:cs typeface="+mn-cs"/>
+            </a:endParaRPr>
+          </a:p>
+          <a:p>
+            <a:r>
+              <a:rPr lang="en-US" sz="1200" b="0" i="0" kern="1200" dirty="0">
+                <a:solidFill>
+                  <a:schemeClr val="tx1"/>
+                </a:solidFill>
+                <a:effectLst/>
+                <a:latin typeface="+mn-lt"/>
+                <a:ea typeface="+mn-ea"/>
+                <a:cs typeface="+mn-cs"/>
+              </a:rPr>
+              <a:t>plus it contains </a:t>
+            </a:r>
+            <a:br>
+              <a:rPr lang="en-US" sz="1200" b="0" i="0" kern="1200" dirty="0">
+                <a:solidFill>
+                  <a:schemeClr val="tx1"/>
+                </a:solidFill>
+                <a:effectLst/>
+                <a:latin typeface="+mn-lt"/>
+                <a:ea typeface="+mn-ea"/>
+                <a:cs typeface="+mn-cs"/>
+              </a:rPr>
+            </a:br>
+            <a:r>
+              <a:rPr lang="en-US" sz="1200" b="0" i="0" kern="1200" dirty="0">
+                <a:solidFill>
+                  <a:schemeClr val="tx1"/>
+                </a:solidFill>
+                <a:effectLst/>
+                <a:latin typeface="+mn-lt"/>
+                <a:ea typeface="+mn-ea"/>
+                <a:cs typeface="+mn-cs"/>
+              </a:rPr>
+              <a:t>static corpus to provide fallback </a:t>
+            </a:r>
+            <a:br>
+              <a:rPr lang="en-US" sz="1200" b="0" i="0" kern="1200" dirty="0">
+                <a:solidFill>
+                  <a:schemeClr val="tx1"/>
+                </a:solidFill>
+                <a:effectLst/>
+                <a:latin typeface="+mn-lt"/>
+                <a:ea typeface="+mn-ea"/>
+                <a:cs typeface="+mn-cs"/>
+              </a:rPr>
+            </a:br>
+            <a:r>
+              <a:rPr lang="en-US" sz="1200" b="0" i="0" kern="1200" dirty="0">
+                <a:solidFill>
+                  <a:schemeClr val="tx1"/>
+                </a:solidFill>
+                <a:effectLst/>
+                <a:latin typeface="+mn-lt"/>
+                <a:ea typeface="+mn-ea"/>
+                <a:cs typeface="+mn-cs"/>
+              </a:rPr>
+              <a:t>if any service is unavailable during review</a:t>
+            </a:r>
+            <a:endParaRPr dirty="0"/>
           </a:p>
         </p:txBody>
       </p:sp>
@@ -3670,6 +4200,329 @@
         <p:spPr/>
       </p:sp>
     </p:spTree>
+  </p:cSld>
+  <p:clrMapOvr>
+    <a:masterClrMapping/>
+  </p:clrMapOvr>
+</p:notes>
+</file>
+
+<file path=ppt/notesSlides/notesSlide11.xml><?xml version="1.0" encoding="utf-8"?>
+<p:notes xmlns:a="http://schemas.openxmlformats.org/drawingml/2006/main" xmlns:r="http://schemas.openxmlformats.org/officeDocument/2006/relationships" xmlns:p="http://schemas.openxmlformats.org/presentationml/2006/main">
+  <p:cSld>
+    <p:spTree>
+      <p:nvGrpSpPr>
+        <p:cNvPr id="1" name=""/>
+        <p:cNvGrpSpPr/>
+        <p:nvPr/>
+      </p:nvGrpSpPr>
+      <p:grpSpPr>
+        <a:xfrm>
+          <a:off x="0" y="0"/>
+          <a:ext cx="0" cy="0"/>
+          <a:chOff x="0" y="0"/>
+          <a:chExt cx="0" cy="0"/>
+        </a:xfrm>
+      </p:grpSpPr>
+      <p:sp>
+        <p:nvSpPr>
+          <p:cNvPr id="2" name="Slide Image Placeholder 1"/>
+          <p:cNvSpPr>
+            <a:spLocks noGrp="1" noRot="1" noChangeAspect="1"/>
+          </p:cNvSpPr>
+          <p:nvPr>
+            <p:ph type="sldImg" idx="2"/>
+          </p:nvPr>
+        </p:nvSpPr>
+        <p:spPr/>
+      </p:sp>
+      <p:sp>
+        <p:nvSpPr>
+          <p:cNvPr id="3" name="Notes Placeholder 2"/>
+          <p:cNvSpPr>
+            <a:spLocks noGrp="1"/>
+          </p:cNvSpPr>
+          <p:nvPr>
+            <p:ph type="body" sz="quarter" idx="3"/>
+          </p:nvPr>
+        </p:nvSpPr>
+        <p:spPr/>
+        <p:txBody>
+          <a:bodyPr/>
+          <a:lstStyle/>
+          <a:p>
+            <a:r>
+              <a:rPr lang="en-US" sz="1200" b="0" i="0" kern="1200" dirty="0">
+                <a:solidFill>
+                  <a:schemeClr val="tx1"/>
+                </a:solidFill>
+                <a:effectLst/>
+                <a:latin typeface="+mn-lt"/>
+                <a:ea typeface="+mn-ea"/>
+                <a:cs typeface="+mn-cs"/>
+              </a:rPr>
+              <a:t>There are some limitations. </a:t>
+            </a:r>
+          </a:p>
+          <a:p>
+            <a:r>
+              <a:rPr lang="en-US" sz="1200" b="0" i="0" kern="1200" dirty="0">
+                <a:solidFill>
+                  <a:schemeClr val="tx1"/>
+                </a:solidFill>
+                <a:effectLst/>
+                <a:latin typeface="+mn-lt"/>
+                <a:ea typeface="+mn-ea"/>
+                <a:cs typeface="+mn-cs"/>
+              </a:rPr>
+              <a:t>Local-first deployment </a:t>
+            </a:r>
+          </a:p>
+          <a:p>
+            <a:r>
+              <a:rPr lang="en-US" sz="1200" b="0" i="0" kern="1200" dirty="0">
+                <a:solidFill>
+                  <a:schemeClr val="tx1"/>
+                </a:solidFill>
+                <a:effectLst/>
+                <a:latin typeface="+mn-lt"/>
+                <a:ea typeface="+mn-ea"/>
+                <a:cs typeface="+mn-cs"/>
+              </a:rPr>
+              <a:t>and a tightly controlled topics </a:t>
+            </a:r>
+          </a:p>
+          <a:p>
+            <a:r>
+              <a:rPr lang="en-US" sz="1200" b="0" i="0" kern="1200" dirty="0">
+                <a:solidFill>
+                  <a:schemeClr val="tx1"/>
+                </a:solidFill>
+                <a:effectLst/>
+                <a:latin typeface="+mn-lt"/>
+                <a:ea typeface="+mn-ea"/>
+                <a:cs typeface="+mn-cs"/>
+              </a:rPr>
+              <a:t>were conscious scope decisions, not hidden gaps. </a:t>
+            </a:r>
+          </a:p>
+          <a:p>
+            <a:endParaRPr lang="en-US" sz="1200" b="0" i="0" kern="1200" dirty="0">
+              <a:solidFill>
+                <a:schemeClr val="tx1"/>
+              </a:solidFill>
+              <a:effectLst/>
+              <a:latin typeface="+mn-lt"/>
+              <a:ea typeface="+mn-ea"/>
+              <a:cs typeface="+mn-cs"/>
+            </a:endParaRPr>
+          </a:p>
+          <a:p>
+            <a:r>
+              <a:rPr lang="en-US" sz="1200" b="0" i="0" kern="1200" dirty="0">
+                <a:solidFill>
+                  <a:schemeClr val="tx1"/>
+                </a:solidFill>
+                <a:effectLst/>
+                <a:latin typeface="+mn-lt"/>
+                <a:ea typeface="+mn-ea"/>
+                <a:cs typeface="+mn-cs"/>
+              </a:rPr>
+              <a:t>Future work includes </a:t>
+            </a:r>
+          </a:p>
+          <a:p>
+            <a:r>
+              <a:rPr lang="en-US" sz="1200" b="0" i="0" kern="1200" dirty="0">
+                <a:solidFill>
+                  <a:schemeClr val="tx1"/>
+                </a:solidFill>
+                <a:effectLst/>
+                <a:latin typeface="+mn-lt"/>
+                <a:ea typeface="+mn-ea"/>
+                <a:cs typeface="+mn-cs"/>
+              </a:rPr>
+              <a:t>broader corpus expansion, </a:t>
+            </a:r>
+          </a:p>
+          <a:p>
+            <a:r>
+              <a:rPr lang="en-US" sz="1200" b="0" i="0" kern="1200" dirty="0">
+                <a:solidFill>
+                  <a:schemeClr val="tx1"/>
+                </a:solidFill>
+                <a:effectLst/>
+                <a:latin typeface="+mn-lt"/>
+                <a:ea typeface="+mn-ea"/>
+                <a:cs typeface="+mn-cs"/>
+              </a:rPr>
+              <a:t>deeper evaluation, </a:t>
+            </a:r>
+          </a:p>
+          <a:p>
+            <a:r>
+              <a:rPr lang="en-US" sz="1200" b="0" i="0" kern="1200" dirty="0">
+                <a:solidFill>
+                  <a:schemeClr val="tx1"/>
+                </a:solidFill>
+                <a:effectLst/>
+                <a:latin typeface="+mn-lt"/>
+                <a:ea typeface="+mn-ea"/>
+                <a:cs typeface="+mn-cs"/>
+              </a:rPr>
+              <a:t>and optional graph-native persistence </a:t>
+            </a:r>
+          </a:p>
+          <a:p>
+            <a:r>
+              <a:rPr lang="en-US" sz="1200" b="0" i="0" kern="1200" dirty="0">
+                <a:solidFill>
+                  <a:schemeClr val="tx1"/>
+                </a:solidFill>
+                <a:effectLst/>
+                <a:latin typeface="+mn-lt"/>
+                <a:ea typeface="+mn-ea"/>
+                <a:cs typeface="+mn-cs"/>
+              </a:rPr>
+              <a:t>once the retrieval pipeline is fully validated</a:t>
+            </a:r>
+            <a:endParaRPr dirty="0"/>
+          </a:p>
+        </p:txBody>
+      </p:sp>
+      <p:sp>
+        <p:nvSpPr>
+          <p:cNvPr id="4" name="Slide Number Placeholder 3"/>
+          <p:cNvSpPr>
+            <a:spLocks noGrp="1"/>
+          </p:cNvSpPr>
+          <p:nvPr>
+            <p:ph type="sldNum" sz="quarter" idx="5"/>
+          </p:nvPr>
+        </p:nvSpPr>
+        <p:spPr/>
+      </p:sp>
+    </p:spTree>
+  </p:cSld>
+  <p:clrMapOvr>
+    <a:masterClrMapping/>
+  </p:clrMapOvr>
+</p:notes>
+</file>
+
+<file path=ppt/notesSlides/notesSlide12.xml><?xml version="1.0" encoding="utf-8"?>
+<p:notes xmlns:a="http://schemas.openxmlformats.org/drawingml/2006/main" xmlns:r="http://schemas.openxmlformats.org/officeDocument/2006/relationships" xmlns:p="http://schemas.openxmlformats.org/presentationml/2006/main">
+  <p:cSld>
+    <p:spTree>
+      <p:nvGrpSpPr>
+        <p:cNvPr id="1" name=""/>
+        <p:cNvGrpSpPr/>
+        <p:nvPr/>
+      </p:nvGrpSpPr>
+      <p:grpSpPr>
+        <a:xfrm>
+          <a:off x="0" y="0"/>
+          <a:ext cx="0" cy="0"/>
+          <a:chOff x="0" y="0"/>
+          <a:chExt cx="0" cy="0"/>
+        </a:xfrm>
+      </p:grpSpPr>
+      <p:sp>
+        <p:nvSpPr>
+          <p:cNvPr id="2" name="Slide Image Placeholder 1"/>
+          <p:cNvSpPr>
+            <a:spLocks noGrp="1" noRot="1" noChangeAspect="1"/>
+          </p:cNvSpPr>
+          <p:nvPr>
+            <p:ph type="sldImg"/>
+          </p:nvPr>
+        </p:nvSpPr>
+        <p:spPr>
+          <a:xfrm>
+            <a:off x="685800" y="1143000"/>
+            <a:ext cx="5486400" cy="3086100"/>
+          </a:xfrm>
+          <a:prstGeom prst="rect">
+            <a:avLst/>
+          </a:prstGeom>
+          <a:noFill/>
+          <a:ln w="12700">
+            <a:solidFill>
+              <a:prstClr val="black"/>
+            </a:solidFill>
+          </a:ln>
+        </p:spPr>
+      </p:sp>
+      <p:sp>
+        <p:nvSpPr>
+          <p:cNvPr id="3" name="Notes Placeholder 2"/>
+          <p:cNvSpPr>
+            <a:spLocks noGrp="1"/>
+          </p:cNvSpPr>
+          <p:nvPr>
+            <p:ph type="body" idx="1"/>
+          </p:nvPr>
+        </p:nvSpPr>
+        <p:spPr>
+          <a:xfrm>
+            <a:off x="685800" y="4400550"/>
+            <a:ext cx="5486400" cy="3600450"/>
+          </a:xfrm>
+          <a:prstGeom prst="rect">
+            <a:avLst/>
+          </a:prstGeom>
+        </p:spPr>
+        <p:txBody>
+          <a:bodyPr/>
+          <a:lstStyle/>
+          <a:p>
+            <a:r>
+              <a:rPr lang="en-US" sz="1200" b="0" i="0" kern="1200" dirty="0">
+                <a:solidFill>
+                  <a:schemeClr val="tx1"/>
+                </a:solidFill>
+                <a:effectLst/>
+                <a:latin typeface="+mn-lt"/>
+                <a:ea typeface="+mn-ea"/>
+                <a:cs typeface="+mn-cs"/>
+              </a:rPr>
+              <a:t>The goal again is trustworthy evidence, one passage at a time. </a:t>
+            </a:r>
+          </a:p>
+          <a:p>
+            <a:endParaRPr lang="en-US" sz="1200" b="0" i="0" kern="1200" dirty="0">
+              <a:solidFill>
+                <a:schemeClr val="tx1"/>
+              </a:solidFill>
+              <a:effectLst/>
+              <a:latin typeface="+mn-lt"/>
+              <a:ea typeface="+mn-ea"/>
+              <a:cs typeface="+mn-cs"/>
+            </a:endParaRPr>
+          </a:p>
+          <a:p>
+            <a:r>
+              <a:rPr lang="en-US" sz="1200" b="0" i="0" kern="1200" dirty="0">
+                <a:solidFill>
+                  <a:schemeClr val="tx1"/>
+                </a:solidFill>
+                <a:effectLst/>
+                <a:latin typeface="+mn-lt"/>
+                <a:ea typeface="+mn-ea"/>
+                <a:cs typeface="+mn-cs"/>
+              </a:rPr>
+              <a:t>Thank you for your time.</a:t>
+            </a:r>
+            <a:endParaRPr lang="en-US" dirty="0"/>
+          </a:p>
+        </p:txBody>
+      </p:sp>
+    </p:spTree>
+    <p:extLst>
+      <p:ext uri="{BB962C8B-B14F-4D97-AF65-F5344CB8AC3E}">
+        <p14:creationId xmlns:p14="http://schemas.microsoft.com/office/powerpoint/2010/main" val="825929130"/>
+      </p:ext>
+    </p:extLst>
   </p:cSld>
   <p:clrMapOvr>
     <a:masterClrMapping/>
@@ -3722,8 +4575,168 @@
           <a:lstStyle/>
           <a:p>
             <a:r>
-              <a:t>Walk through the controlled corpus and fail-closed approach. Stress that the system does not silently fall back to general model knowledge.</a:t>
-            </a:r>
+              <a:rPr lang="en-US" sz="1200" b="0" i="0" kern="1200" dirty="0">
+                <a:solidFill>
+                  <a:schemeClr val="tx1"/>
+                </a:solidFill>
+                <a:effectLst/>
+                <a:latin typeface="+mn-lt"/>
+                <a:ea typeface="+mn-ea"/>
+                <a:cs typeface="+mn-cs"/>
+              </a:rPr>
+              <a:t>The core problem we’re solving is not access to a language model. </a:t>
+            </a:r>
+          </a:p>
+          <a:p>
+            <a:endParaRPr lang="en-US" sz="1200" b="0" i="0" kern="1200" dirty="0">
+              <a:solidFill>
+                <a:schemeClr val="tx1"/>
+              </a:solidFill>
+              <a:effectLst/>
+              <a:latin typeface="+mn-lt"/>
+              <a:ea typeface="+mn-ea"/>
+              <a:cs typeface="+mn-cs"/>
+            </a:endParaRPr>
+          </a:p>
+          <a:p>
+            <a:r>
+              <a:rPr lang="en-US" sz="1200" b="0" i="0" kern="1200" dirty="0">
+                <a:solidFill>
+                  <a:schemeClr val="tx1"/>
+                </a:solidFill>
+                <a:effectLst/>
+                <a:latin typeface="+mn-lt"/>
+                <a:ea typeface="+mn-ea"/>
+                <a:cs typeface="+mn-cs"/>
+              </a:rPr>
+              <a:t>Researchers already have that. </a:t>
+            </a:r>
+          </a:p>
+          <a:p>
+            <a:endParaRPr lang="en-US" sz="1200" b="0" i="0" kern="1200" dirty="0">
+              <a:solidFill>
+                <a:schemeClr val="tx1"/>
+              </a:solidFill>
+              <a:effectLst/>
+              <a:latin typeface="+mn-lt"/>
+              <a:ea typeface="+mn-ea"/>
+              <a:cs typeface="+mn-cs"/>
+            </a:endParaRPr>
+          </a:p>
+          <a:p>
+            <a:r>
+              <a:rPr lang="en-US" sz="1200" b="0" i="0" kern="1200" dirty="0">
+                <a:solidFill>
+                  <a:schemeClr val="tx1"/>
+                </a:solidFill>
+                <a:effectLst/>
+                <a:latin typeface="+mn-lt"/>
+                <a:ea typeface="+mn-ea"/>
+                <a:cs typeface="+mn-cs"/>
+              </a:rPr>
+              <a:t>The real problem is evidence discovery with scientific provenance and explicit limits. </a:t>
+            </a:r>
+          </a:p>
+          <a:p>
+            <a:endParaRPr lang="en-US" sz="1200" b="0" i="0" kern="1200" dirty="0">
+              <a:solidFill>
+                <a:schemeClr val="tx1"/>
+              </a:solidFill>
+              <a:effectLst/>
+              <a:latin typeface="+mn-lt"/>
+              <a:ea typeface="+mn-ea"/>
+              <a:cs typeface="+mn-cs"/>
+            </a:endParaRPr>
+          </a:p>
+          <a:p>
+            <a:r>
+              <a:rPr lang="en-US" sz="1200" b="0" i="0" kern="1200" dirty="0">
+                <a:solidFill>
+                  <a:schemeClr val="tx1"/>
+                </a:solidFill>
+                <a:effectLst/>
+                <a:latin typeface="+mn-lt"/>
+                <a:ea typeface="+mn-ea"/>
+                <a:cs typeface="+mn-cs"/>
+              </a:rPr>
+              <a:t>We need to know where an answer comes from, </a:t>
+            </a:r>
+          </a:p>
+          <a:p>
+            <a:endParaRPr lang="en-US" sz="1200" b="0" i="0" kern="1200" dirty="0">
+              <a:solidFill>
+                <a:schemeClr val="tx1"/>
+              </a:solidFill>
+              <a:effectLst/>
+              <a:latin typeface="+mn-lt"/>
+              <a:ea typeface="+mn-ea"/>
+              <a:cs typeface="+mn-cs"/>
+            </a:endParaRPr>
+          </a:p>
+          <a:p>
+            <a:r>
+              <a:rPr lang="en-US" sz="1200" b="0" i="0" kern="1200" dirty="0">
+                <a:solidFill>
+                  <a:schemeClr val="tx1"/>
+                </a:solidFill>
+                <a:effectLst/>
+                <a:latin typeface="+mn-lt"/>
+                <a:ea typeface="+mn-ea"/>
+                <a:cs typeface="+mn-cs"/>
+              </a:rPr>
+              <a:t>what study it is based on, </a:t>
+            </a:r>
+          </a:p>
+          <a:p>
+            <a:endParaRPr lang="en-US" sz="1200" b="0" i="0" kern="1200" dirty="0">
+              <a:solidFill>
+                <a:schemeClr val="tx1"/>
+              </a:solidFill>
+              <a:effectLst/>
+              <a:latin typeface="+mn-lt"/>
+              <a:ea typeface="+mn-ea"/>
+              <a:cs typeface="+mn-cs"/>
+            </a:endParaRPr>
+          </a:p>
+          <a:p>
+            <a:r>
+              <a:rPr lang="en-US" sz="1200" b="0" i="0" kern="1200" dirty="0">
+                <a:solidFill>
+                  <a:schemeClr val="tx1"/>
+                </a:solidFill>
+                <a:effectLst/>
+                <a:latin typeface="+mn-lt"/>
+                <a:ea typeface="+mn-ea"/>
+                <a:cs typeface="+mn-cs"/>
+              </a:rPr>
+              <a:t>and when the evidence is simply not strong </a:t>
+            </a:r>
+          </a:p>
+          <a:p>
+            <a:endParaRPr lang="en-US" sz="1200" b="0" i="0" kern="1200" dirty="0">
+              <a:solidFill>
+                <a:schemeClr val="tx1"/>
+              </a:solidFill>
+              <a:effectLst/>
+              <a:latin typeface="+mn-lt"/>
+              <a:ea typeface="+mn-ea"/>
+              <a:cs typeface="+mn-cs"/>
+            </a:endParaRPr>
+          </a:p>
+          <a:p>
+            <a:r>
+              <a:rPr lang="en-US" sz="1200" b="0" i="0" kern="1200" dirty="0">
+                <a:solidFill>
+                  <a:schemeClr val="tx1"/>
+                </a:solidFill>
+                <a:effectLst/>
+                <a:latin typeface="+mn-lt"/>
+                <a:ea typeface="+mn-ea"/>
+                <a:cs typeface="+mn-cs"/>
+              </a:rPr>
+              <a:t>enough to support a claim</a:t>
+            </a:r>
+            <a:endParaRPr dirty="0"/>
           </a:p>
         </p:txBody>
       </p:sp>
@@ -3792,8 +4805,152 @@
           <a:lstStyle/>
           <a:p>
             <a:r>
-              <a:t>Describe the data flow left to right. The same provenance fields survive extraction, retrieval, answer generation, and citation display.</a:t>
-            </a:r>
+              <a:rPr lang="en-US" sz="1200" b="0" i="0" kern="1200" dirty="0">
+                <a:solidFill>
+                  <a:schemeClr val="tx1"/>
+                </a:solidFill>
+                <a:effectLst/>
+                <a:latin typeface="+mn-lt"/>
+                <a:ea typeface="+mn-ea"/>
+                <a:cs typeface="+mn-cs"/>
+              </a:rPr>
+              <a:t>Our solution is a controlled corpus and a fail-closed design. </a:t>
+            </a:r>
+          </a:p>
+          <a:p>
+            <a:endParaRPr lang="en-US" sz="1200" b="0" i="0" kern="1200" dirty="0">
+              <a:solidFill>
+                <a:schemeClr val="tx1"/>
+              </a:solidFill>
+              <a:effectLst/>
+              <a:latin typeface="+mn-lt"/>
+              <a:ea typeface="+mn-ea"/>
+              <a:cs typeface="+mn-cs"/>
+            </a:endParaRPr>
+          </a:p>
+          <a:p>
+            <a:r>
+              <a:rPr lang="en-US" sz="1200" b="0" i="0" kern="1200" dirty="0">
+                <a:solidFill>
+                  <a:schemeClr val="tx1"/>
+                </a:solidFill>
+                <a:effectLst/>
+                <a:latin typeface="+mn-lt"/>
+                <a:ea typeface="+mn-ea"/>
+                <a:cs typeface="+mn-cs"/>
+              </a:rPr>
+              <a:t>The system only answers from </a:t>
+            </a:r>
+            <a:br>
+              <a:rPr lang="en-US" sz="1200" b="0" i="0" kern="1200" dirty="0">
+                <a:solidFill>
+                  <a:schemeClr val="tx1"/>
+                </a:solidFill>
+                <a:effectLst/>
+                <a:latin typeface="+mn-lt"/>
+                <a:ea typeface="+mn-ea"/>
+                <a:cs typeface="+mn-cs"/>
+              </a:rPr>
+            </a:br>
+            <a:r>
+              <a:rPr lang="en-US" sz="1200" b="0" i="0" kern="1200" dirty="0">
+                <a:solidFill>
+                  <a:schemeClr val="tx1"/>
+                </a:solidFill>
+                <a:effectLst/>
+                <a:latin typeface="+mn-lt"/>
+                <a:ea typeface="+mn-ea"/>
+                <a:cs typeface="+mn-cs"/>
+              </a:rPr>
+              <a:t>an approved set of open-access publications. </a:t>
+            </a:r>
+          </a:p>
+          <a:p>
+            <a:endParaRPr lang="en-US" sz="1200" b="0" i="0" kern="1200" dirty="0">
+              <a:solidFill>
+                <a:schemeClr val="tx1"/>
+              </a:solidFill>
+              <a:effectLst/>
+              <a:latin typeface="+mn-lt"/>
+              <a:ea typeface="+mn-ea"/>
+              <a:cs typeface="+mn-cs"/>
+            </a:endParaRPr>
+          </a:p>
+          <a:p>
+            <a:r>
+              <a:rPr lang="en-US" sz="1200" b="0" i="0" kern="1200" dirty="0">
+                <a:solidFill>
+                  <a:schemeClr val="tx1"/>
+                </a:solidFill>
+                <a:effectLst/>
+                <a:latin typeface="+mn-lt"/>
+                <a:ea typeface="+mn-ea"/>
+                <a:cs typeface="+mn-cs"/>
+              </a:rPr>
+              <a:t>If it cannot retrieve supporting passages, </a:t>
+            </a:r>
+          </a:p>
+          <a:p>
+            <a:endParaRPr lang="en-US" sz="1200" b="0" i="0" kern="1200" dirty="0">
+              <a:solidFill>
+                <a:schemeClr val="tx1"/>
+              </a:solidFill>
+              <a:effectLst/>
+              <a:latin typeface="+mn-lt"/>
+              <a:ea typeface="+mn-ea"/>
+              <a:cs typeface="+mn-cs"/>
+            </a:endParaRPr>
+          </a:p>
+          <a:p>
+            <a:r>
+              <a:rPr lang="en-US" sz="1200" b="0" i="0" kern="1200" dirty="0">
+                <a:solidFill>
+                  <a:schemeClr val="tx1"/>
+                </a:solidFill>
+                <a:effectLst/>
+                <a:latin typeface="+mn-lt"/>
+                <a:ea typeface="+mn-ea"/>
+                <a:cs typeface="+mn-cs"/>
+              </a:rPr>
+              <a:t>it does not silently fall back to general model knowledge. </a:t>
+            </a:r>
+          </a:p>
+          <a:p>
+            <a:endParaRPr lang="en-US" sz="1200" b="0" i="0" kern="1200" dirty="0">
+              <a:solidFill>
+                <a:schemeClr val="tx1"/>
+              </a:solidFill>
+              <a:effectLst/>
+              <a:latin typeface="+mn-lt"/>
+              <a:ea typeface="+mn-ea"/>
+              <a:cs typeface="+mn-cs"/>
+            </a:endParaRPr>
+          </a:p>
+          <a:p>
+            <a:r>
+              <a:rPr lang="en-US" sz="1200" b="0" i="0" kern="1200" dirty="0">
+                <a:solidFill>
+                  <a:schemeClr val="tx1"/>
+                </a:solidFill>
+                <a:effectLst/>
+                <a:latin typeface="+mn-lt"/>
+                <a:ea typeface="+mn-ea"/>
+                <a:cs typeface="+mn-cs"/>
+              </a:rPr>
+              <a:t>It tells the user the evidence is insufficient</a:t>
+            </a:r>
+            <a:br>
+              <a:rPr lang="en-US" sz="1200" b="0" i="0" kern="1200" dirty="0">
+                <a:solidFill>
+                  <a:schemeClr val="tx1"/>
+                </a:solidFill>
+                <a:effectLst/>
+                <a:latin typeface="+mn-lt"/>
+                <a:ea typeface="+mn-ea"/>
+                <a:cs typeface="+mn-cs"/>
+              </a:rPr>
+            </a:br>
+            <a:endParaRPr dirty="0"/>
           </a:p>
         </p:txBody>
       </p:sp>
@@ -3862,8 +5019,246 @@
           <a:lstStyle/>
           <a:p>
             <a:r>
-              <a:t>Demonstrate the Ask form. Explain that every answer claim should map to a retrieved citation and that unsupported generation is rejected.</a:t>
-            </a:r>
+              <a:rPr lang="en-US" sz="1200" b="0" i="0" kern="1200" dirty="0">
+                <a:solidFill>
+                  <a:schemeClr val="tx1"/>
+                </a:solidFill>
+                <a:effectLst/>
+                <a:latin typeface="+mn-lt"/>
+                <a:ea typeface="+mn-ea"/>
+                <a:cs typeface="+mn-cs"/>
+              </a:rPr>
+              <a:t>Here is the architecture. </a:t>
+            </a:r>
+          </a:p>
+          <a:p>
+            <a:endParaRPr lang="en-US" sz="1200" b="0" i="0" kern="1200" dirty="0">
+              <a:solidFill>
+                <a:schemeClr val="tx1"/>
+              </a:solidFill>
+              <a:effectLst/>
+              <a:latin typeface="+mn-lt"/>
+              <a:ea typeface="+mn-ea"/>
+              <a:cs typeface="+mn-cs"/>
+            </a:endParaRPr>
+          </a:p>
+          <a:p>
+            <a:r>
+              <a:rPr lang="en-US" sz="1200" b="0" i="0" kern="1200" dirty="0">
+                <a:solidFill>
+                  <a:schemeClr val="tx1"/>
+                </a:solidFill>
+                <a:effectLst/>
+                <a:latin typeface="+mn-lt"/>
+                <a:ea typeface="+mn-ea"/>
+                <a:cs typeface="+mn-cs"/>
+              </a:rPr>
+              <a:t>Data flows from approved PDFs through extraction, chunking, and embedding into PostgreSQL</a:t>
+            </a:r>
+            <a:br>
+              <a:rPr lang="en-US" sz="1200" b="0" i="0" kern="1200" dirty="0">
+                <a:solidFill>
+                  <a:schemeClr val="tx1"/>
+                </a:solidFill>
+                <a:effectLst/>
+                <a:latin typeface="+mn-lt"/>
+                <a:ea typeface="+mn-ea"/>
+                <a:cs typeface="+mn-cs"/>
+              </a:rPr>
+            </a:br>
+            <a:r>
+              <a:rPr lang="en-US" sz="1200" b="0" i="0" kern="1200" dirty="0">
+                <a:solidFill>
+                  <a:schemeClr val="tx1"/>
+                </a:solidFill>
+                <a:effectLst/>
+                <a:latin typeface="+mn-lt"/>
+                <a:ea typeface="+mn-ea"/>
+                <a:cs typeface="+mn-cs"/>
+              </a:rPr>
+              <a:t> with p g vector. </a:t>
+            </a:r>
+          </a:p>
+          <a:p>
+            <a:endParaRPr lang="en-US" sz="1200" b="0" i="0" kern="1200" dirty="0">
+              <a:solidFill>
+                <a:schemeClr val="tx1"/>
+              </a:solidFill>
+              <a:effectLst/>
+              <a:latin typeface="+mn-lt"/>
+              <a:ea typeface="+mn-ea"/>
+              <a:cs typeface="+mn-cs"/>
+            </a:endParaRPr>
+          </a:p>
+          <a:p>
+            <a:r>
+              <a:rPr lang="en-US" sz="1200" b="0" i="0" kern="1200" dirty="0">
+                <a:solidFill>
+                  <a:schemeClr val="tx1"/>
+                </a:solidFill>
+                <a:effectLst/>
+                <a:latin typeface="+mn-lt"/>
+                <a:ea typeface="+mn-ea"/>
+                <a:cs typeface="+mn-cs"/>
+              </a:rPr>
+              <a:t>Retrieval then selects passages, </a:t>
+            </a:r>
+          </a:p>
+          <a:p>
+            <a:endParaRPr lang="en-US" sz="1200" b="0" i="0" kern="1200" dirty="0">
+              <a:solidFill>
+                <a:schemeClr val="tx1"/>
+              </a:solidFill>
+              <a:effectLst/>
+              <a:latin typeface="+mn-lt"/>
+              <a:ea typeface="+mn-ea"/>
+              <a:cs typeface="+mn-cs"/>
+            </a:endParaRPr>
+          </a:p>
+          <a:p>
+            <a:r>
+              <a:rPr lang="en-US" sz="1200" b="0" i="0" kern="1200" dirty="0">
+                <a:solidFill>
+                  <a:schemeClr val="tx1"/>
+                </a:solidFill>
+                <a:effectLst/>
+                <a:latin typeface="+mn-lt"/>
+                <a:ea typeface="+mn-ea"/>
+                <a:cs typeface="+mn-cs"/>
+              </a:rPr>
+              <a:t>the answer generator grounds every claim in those passages, </a:t>
+            </a:r>
+          </a:p>
+          <a:p>
+            <a:endParaRPr lang="en-US" sz="1200" b="0" i="0" kern="1200" dirty="0">
+              <a:solidFill>
+                <a:schemeClr val="tx1"/>
+              </a:solidFill>
+              <a:effectLst/>
+              <a:latin typeface="+mn-lt"/>
+              <a:ea typeface="+mn-ea"/>
+              <a:cs typeface="+mn-cs"/>
+            </a:endParaRPr>
+          </a:p>
+          <a:p>
+            <a:r>
+              <a:rPr lang="en-US" sz="1200" b="0" i="0" kern="1200" dirty="0">
+                <a:solidFill>
+                  <a:schemeClr val="tx1"/>
+                </a:solidFill>
+                <a:effectLst/>
+                <a:latin typeface="+mn-lt"/>
+                <a:ea typeface="+mn-ea"/>
+                <a:cs typeface="+mn-cs"/>
+              </a:rPr>
+              <a:t>and the UI displays citations back </a:t>
+            </a:r>
+            <a:br>
+              <a:rPr lang="en-US" sz="1200" b="0" i="0" kern="1200" dirty="0">
+                <a:solidFill>
+                  <a:schemeClr val="tx1"/>
+                </a:solidFill>
+                <a:effectLst/>
+                <a:latin typeface="+mn-lt"/>
+                <a:ea typeface="+mn-ea"/>
+                <a:cs typeface="+mn-cs"/>
+              </a:rPr>
+            </a:br>
+            <a:r>
+              <a:rPr lang="en-US" sz="1200" b="0" i="0" kern="1200" dirty="0">
+                <a:solidFill>
+                  <a:schemeClr val="tx1"/>
+                </a:solidFill>
+                <a:effectLst/>
+                <a:latin typeface="+mn-lt"/>
+                <a:ea typeface="+mn-ea"/>
+                <a:cs typeface="+mn-cs"/>
+              </a:rPr>
+              <a:t>to the original publication, section, </a:t>
+            </a:r>
+            <a:br>
+              <a:rPr lang="en-US" sz="1200" b="0" i="0" kern="1200" dirty="0">
+                <a:solidFill>
+                  <a:schemeClr val="tx1"/>
+                </a:solidFill>
+                <a:effectLst/>
+                <a:latin typeface="+mn-lt"/>
+                <a:ea typeface="+mn-ea"/>
+                <a:cs typeface="+mn-cs"/>
+              </a:rPr>
+            </a:br>
+            <a:r>
+              <a:rPr lang="en-US" sz="1200" b="0" i="0" kern="1200" dirty="0">
+                <a:solidFill>
+                  <a:schemeClr val="tx1"/>
+                </a:solidFill>
+                <a:effectLst/>
+                <a:latin typeface="+mn-lt"/>
+                <a:ea typeface="+mn-ea"/>
+                <a:cs typeface="+mn-cs"/>
+              </a:rPr>
+              <a:t>and page. </a:t>
+            </a:r>
+          </a:p>
+          <a:p>
+            <a:endParaRPr lang="en-US" sz="1200" b="0" i="0" kern="1200" dirty="0">
+              <a:solidFill>
+                <a:schemeClr val="tx1"/>
+              </a:solidFill>
+              <a:effectLst/>
+              <a:latin typeface="+mn-lt"/>
+              <a:ea typeface="+mn-ea"/>
+              <a:cs typeface="+mn-cs"/>
+            </a:endParaRPr>
+          </a:p>
+          <a:p>
+            <a:r>
+              <a:rPr lang="en-US" sz="1200" b="0" i="0" kern="1200" dirty="0">
+                <a:solidFill>
+                  <a:schemeClr val="tx1"/>
+                </a:solidFill>
+                <a:effectLst/>
+                <a:latin typeface="+mn-lt"/>
+                <a:ea typeface="+mn-ea"/>
+                <a:cs typeface="+mn-cs"/>
+              </a:rPr>
+              <a:t>The same provenance fields survive </a:t>
+            </a:r>
+            <a:br>
+              <a:rPr lang="en-US" sz="1200" b="0" i="0" kern="1200" dirty="0">
+                <a:solidFill>
+                  <a:schemeClr val="tx1"/>
+                </a:solidFill>
+                <a:effectLst/>
+                <a:latin typeface="+mn-lt"/>
+                <a:ea typeface="+mn-ea"/>
+                <a:cs typeface="+mn-cs"/>
+              </a:rPr>
+            </a:br>
+            <a:r>
+              <a:rPr lang="en-US" sz="1200" b="0" i="0" kern="1200" dirty="0">
+                <a:solidFill>
+                  <a:schemeClr val="tx1"/>
+                </a:solidFill>
+                <a:effectLst/>
+                <a:latin typeface="+mn-lt"/>
+                <a:ea typeface="+mn-ea"/>
+                <a:cs typeface="+mn-cs"/>
+              </a:rPr>
+              <a:t>the entire pipeline</a:t>
+            </a:r>
+            <a:br>
+              <a:rPr lang="en-US" sz="1200" b="0" i="0" kern="1200" dirty="0">
+                <a:solidFill>
+                  <a:schemeClr val="tx1"/>
+                </a:solidFill>
+                <a:effectLst/>
+                <a:latin typeface="+mn-lt"/>
+                <a:ea typeface="+mn-ea"/>
+                <a:cs typeface="+mn-cs"/>
+              </a:rPr>
+            </a:br>
+            <a:endParaRPr dirty="0"/>
           </a:p>
         </p:txBody>
       </p:sp>
@@ -3932,8 +5327,184 @@
           <a:lstStyle/>
           <a:p>
             <a:r>
-              <a:t>Show that users can inspect the approved corpus and open individual publication metadata, DOI, license, organism, exposure, and ingest status.</a:t>
-            </a:r>
+              <a:rPr lang="en-US" sz="1200" b="0" i="0" kern="1200" dirty="0">
+                <a:solidFill>
+                  <a:schemeClr val="tx1"/>
+                </a:solidFill>
+                <a:effectLst/>
+                <a:latin typeface="+mn-lt"/>
+                <a:ea typeface="+mn-ea"/>
+                <a:cs typeface="+mn-cs"/>
+              </a:rPr>
+              <a:t>Here you can see the Ask interface. </a:t>
+            </a:r>
+          </a:p>
+          <a:p>
+            <a:endParaRPr lang="en-US" sz="1200" b="0" i="0" kern="1200" dirty="0">
+              <a:solidFill>
+                <a:schemeClr val="tx1"/>
+              </a:solidFill>
+              <a:effectLst/>
+              <a:latin typeface="+mn-lt"/>
+              <a:ea typeface="+mn-ea"/>
+              <a:cs typeface="+mn-cs"/>
+            </a:endParaRPr>
+          </a:p>
+          <a:p>
+            <a:r>
+              <a:rPr lang="en-US" sz="1200" b="0" i="0" kern="1200" dirty="0">
+                <a:solidFill>
+                  <a:schemeClr val="tx1"/>
+                </a:solidFill>
+                <a:effectLst/>
+                <a:latin typeface="+mn-lt"/>
+                <a:ea typeface="+mn-ea"/>
+                <a:cs typeface="+mn-cs"/>
+              </a:rPr>
+              <a:t>The user asks a scientific question. </a:t>
+            </a:r>
+          </a:p>
+          <a:p>
+            <a:endParaRPr lang="en-US" sz="1200" b="0" i="0" kern="1200" dirty="0">
+              <a:solidFill>
+                <a:schemeClr val="tx1"/>
+              </a:solidFill>
+              <a:effectLst/>
+              <a:latin typeface="+mn-lt"/>
+              <a:ea typeface="+mn-ea"/>
+              <a:cs typeface="+mn-cs"/>
+            </a:endParaRPr>
+          </a:p>
+          <a:p>
+            <a:r>
+              <a:rPr lang="en-US" sz="1200" b="0" i="0" kern="1200" dirty="0">
+                <a:solidFill>
+                  <a:schemeClr val="tx1"/>
+                </a:solidFill>
+                <a:effectLst/>
+                <a:latin typeface="+mn-lt"/>
+                <a:ea typeface="+mn-ea"/>
+                <a:cs typeface="+mn-cs"/>
+              </a:rPr>
+              <a:t>The system retrieves relevant passages </a:t>
+            </a:r>
+            <a:br>
+              <a:rPr lang="en-US" sz="1200" b="0" i="0" kern="1200" dirty="0">
+                <a:solidFill>
+                  <a:schemeClr val="tx1"/>
+                </a:solidFill>
+                <a:effectLst/>
+                <a:latin typeface="+mn-lt"/>
+                <a:ea typeface="+mn-ea"/>
+                <a:cs typeface="+mn-cs"/>
+              </a:rPr>
+            </a:br>
+            <a:r>
+              <a:rPr lang="en-US" sz="1200" b="0" i="0" kern="1200" dirty="0">
+                <a:solidFill>
+                  <a:schemeClr val="tx1"/>
+                </a:solidFill>
+                <a:effectLst/>
+                <a:latin typeface="+mn-lt"/>
+                <a:ea typeface="+mn-ea"/>
+                <a:cs typeface="+mn-cs"/>
+              </a:rPr>
+              <a:t>and generates an answer </a:t>
+            </a:r>
+            <a:br>
+              <a:rPr lang="en-US" sz="1200" b="0" i="0" kern="1200" dirty="0">
+                <a:solidFill>
+                  <a:schemeClr val="tx1"/>
+                </a:solidFill>
+                <a:effectLst/>
+                <a:latin typeface="+mn-lt"/>
+                <a:ea typeface="+mn-ea"/>
+                <a:cs typeface="+mn-cs"/>
+              </a:rPr>
+            </a:br>
+            <a:r>
+              <a:rPr lang="en-US" sz="1200" b="0" i="0" kern="1200" dirty="0">
+                <a:solidFill>
+                  <a:schemeClr val="tx1"/>
+                </a:solidFill>
+                <a:effectLst/>
+                <a:latin typeface="+mn-lt"/>
+                <a:ea typeface="+mn-ea"/>
+                <a:cs typeface="+mn-cs"/>
+              </a:rPr>
+              <a:t>in which every claim maps to a retrieved citation. </a:t>
+            </a:r>
+          </a:p>
+          <a:p>
+            <a:endParaRPr lang="en-US" sz="1200" b="0" i="0" kern="1200" dirty="0">
+              <a:solidFill>
+                <a:schemeClr val="tx1"/>
+              </a:solidFill>
+              <a:effectLst/>
+              <a:latin typeface="+mn-lt"/>
+              <a:ea typeface="+mn-ea"/>
+              <a:cs typeface="+mn-cs"/>
+            </a:endParaRPr>
+          </a:p>
+          <a:p>
+            <a:r>
+              <a:rPr lang="en-US" sz="1200" b="0" i="0" kern="1200" dirty="0">
+                <a:solidFill>
+                  <a:schemeClr val="tx1"/>
+                </a:solidFill>
+                <a:effectLst/>
+                <a:latin typeface="+mn-lt"/>
+                <a:ea typeface="+mn-ea"/>
+                <a:cs typeface="+mn-cs"/>
+              </a:rPr>
+              <a:t>If no passages support a claim, </a:t>
+            </a:r>
+            <a:br>
+              <a:rPr lang="en-US" sz="1200" b="0" i="0" kern="1200" dirty="0">
+                <a:solidFill>
+                  <a:schemeClr val="tx1"/>
+                </a:solidFill>
+                <a:effectLst/>
+                <a:latin typeface="+mn-lt"/>
+                <a:ea typeface="+mn-ea"/>
+                <a:cs typeface="+mn-cs"/>
+              </a:rPr>
+            </a:br>
+            <a:r>
+              <a:rPr lang="en-US" sz="1200" b="0" i="0" kern="1200" dirty="0">
+                <a:solidFill>
+                  <a:schemeClr val="tx1"/>
+                </a:solidFill>
+                <a:effectLst/>
+                <a:latin typeface="+mn-lt"/>
+                <a:ea typeface="+mn-ea"/>
+                <a:cs typeface="+mn-cs"/>
+              </a:rPr>
+              <a:t>that claim is rejected rather than invented</a:t>
+            </a:r>
+            <a:br>
+              <a:rPr lang="en-US" sz="1200" b="0" i="0" kern="1200" dirty="0">
+                <a:solidFill>
+                  <a:schemeClr val="tx1"/>
+                </a:solidFill>
+                <a:effectLst/>
+                <a:latin typeface="+mn-lt"/>
+                <a:ea typeface="+mn-ea"/>
+                <a:cs typeface="+mn-cs"/>
+              </a:rPr>
+            </a:br>
+            <a:br>
+              <a:rPr lang="en-US" sz="1200" b="0" i="0" kern="1200" dirty="0">
+                <a:solidFill>
+                  <a:schemeClr val="tx1"/>
+                </a:solidFill>
+                <a:effectLst/>
+                <a:latin typeface="+mn-lt"/>
+                <a:ea typeface="+mn-ea"/>
+                <a:cs typeface="+mn-cs"/>
+              </a:rPr>
+            </a:br>
+            <a:endParaRPr dirty="0"/>
           </a:p>
         </p:txBody>
       </p:sp>
@@ -4002,8 +5573,183 @@
           <a:lstStyle/>
           <a:p>
             <a:r>
-              <a:t>Explain semantic/keyword search and the compare workspace. Comparison is metadata-based and deliberately does not invent cross-study findings.</a:t>
-            </a:r>
+              <a:rPr lang="en-US" sz="1200" b="0" i="0" kern="1200" dirty="0">
+                <a:solidFill>
+                  <a:schemeClr val="tx1"/>
+                </a:solidFill>
+                <a:effectLst/>
+                <a:latin typeface="+mn-lt"/>
+                <a:ea typeface="+mn-ea"/>
+                <a:cs typeface="+mn-cs"/>
+              </a:rPr>
+              <a:t>Users can inspect the approved corpus </a:t>
+            </a:r>
+          </a:p>
+          <a:p>
+            <a:endParaRPr lang="en-US" sz="1200" b="0" i="0" kern="1200" dirty="0">
+              <a:solidFill>
+                <a:schemeClr val="tx1"/>
+              </a:solidFill>
+              <a:effectLst/>
+              <a:latin typeface="+mn-lt"/>
+              <a:ea typeface="+mn-ea"/>
+              <a:cs typeface="+mn-cs"/>
+            </a:endParaRPr>
+          </a:p>
+          <a:p>
+            <a:r>
+              <a:rPr lang="en-US" sz="1200" b="0" i="0" kern="1200" dirty="0">
+                <a:solidFill>
+                  <a:schemeClr val="tx1"/>
+                </a:solidFill>
+                <a:effectLst/>
+                <a:latin typeface="+mn-lt"/>
+                <a:ea typeface="+mn-ea"/>
+                <a:cs typeface="+mn-cs"/>
+              </a:rPr>
+              <a:t>and open individual publication metadata: </a:t>
+            </a:r>
+            <a:br>
+              <a:rPr lang="en-US" sz="1200" b="0" i="0" kern="1200" dirty="0">
+                <a:solidFill>
+                  <a:schemeClr val="tx1"/>
+                </a:solidFill>
+                <a:effectLst/>
+                <a:latin typeface="+mn-lt"/>
+                <a:ea typeface="+mn-ea"/>
+                <a:cs typeface="+mn-cs"/>
+              </a:rPr>
+            </a:br>
+            <a:r>
+              <a:rPr lang="en-US" sz="1200" b="0" i="0" kern="1200" dirty="0">
+                <a:solidFill>
+                  <a:schemeClr val="tx1"/>
+                </a:solidFill>
+                <a:effectLst/>
+                <a:latin typeface="+mn-lt"/>
+                <a:ea typeface="+mn-ea"/>
+                <a:cs typeface="+mn-cs"/>
+              </a:rPr>
+              <a:t>title, DOI, license, </a:t>
+            </a:r>
+            <a:br>
+              <a:rPr lang="en-US" sz="1200" b="0" i="0" kern="1200" dirty="0">
+                <a:solidFill>
+                  <a:schemeClr val="tx1"/>
+                </a:solidFill>
+                <a:effectLst/>
+                <a:latin typeface="+mn-lt"/>
+                <a:ea typeface="+mn-ea"/>
+                <a:cs typeface="+mn-cs"/>
+              </a:rPr>
+            </a:br>
+            <a:r>
+              <a:rPr lang="en-US" sz="1200" b="0" i="0" kern="1200" dirty="0">
+                <a:solidFill>
+                  <a:schemeClr val="tx1"/>
+                </a:solidFill>
+                <a:effectLst/>
+                <a:latin typeface="+mn-lt"/>
+                <a:ea typeface="+mn-ea"/>
+                <a:cs typeface="+mn-cs"/>
+              </a:rPr>
+              <a:t>organism, exposure, </a:t>
+            </a:r>
+            <a:br>
+              <a:rPr lang="en-US" sz="1200" b="0" i="0" kern="1200" dirty="0">
+                <a:solidFill>
+                  <a:schemeClr val="tx1"/>
+                </a:solidFill>
+                <a:effectLst/>
+                <a:latin typeface="+mn-lt"/>
+                <a:ea typeface="+mn-ea"/>
+                <a:cs typeface="+mn-cs"/>
+              </a:rPr>
+            </a:br>
+            <a:r>
+              <a:rPr lang="en-US" sz="1200" b="0" i="0" kern="1200" dirty="0">
+                <a:solidFill>
+                  <a:schemeClr val="tx1"/>
+                </a:solidFill>
+                <a:effectLst/>
+                <a:latin typeface="+mn-lt"/>
+                <a:ea typeface="+mn-ea"/>
+                <a:cs typeface="+mn-cs"/>
+              </a:rPr>
+              <a:t>and ingest status. </a:t>
+            </a:r>
+          </a:p>
+          <a:p>
+            <a:endParaRPr lang="en-US" sz="1200" b="0" i="0" kern="1200" dirty="0">
+              <a:solidFill>
+                <a:schemeClr val="tx1"/>
+              </a:solidFill>
+              <a:effectLst/>
+              <a:latin typeface="+mn-lt"/>
+              <a:ea typeface="+mn-ea"/>
+              <a:cs typeface="+mn-cs"/>
+            </a:endParaRPr>
+          </a:p>
+          <a:p>
+            <a:r>
+              <a:rPr lang="en-US" sz="1200" b="0" i="0" kern="1200" dirty="0">
+                <a:solidFill>
+                  <a:schemeClr val="tx1"/>
+                </a:solidFill>
+                <a:effectLst/>
+                <a:latin typeface="+mn-lt"/>
+                <a:ea typeface="+mn-ea"/>
+                <a:cs typeface="+mn-cs"/>
+              </a:rPr>
+              <a:t>Every answer ultimately points back </a:t>
+            </a:r>
+            <a:br>
+              <a:rPr lang="en-US" sz="1200" b="0" i="0" kern="1200" dirty="0">
+                <a:solidFill>
+                  <a:schemeClr val="tx1"/>
+                </a:solidFill>
+                <a:effectLst/>
+                <a:latin typeface="+mn-lt"/>
+                <a:ea typeface="+mn-ea"/>
+                <a:cs typeface="+mn-cs"/>
+              </a:rPr>
+            </a:br>
+            <a:r>
+              <a:rPr lang="en-US" sz="1200" b="0" i="0" kern="1200" dirty="0">
+                <a:solidFill>
+                  <a:schemeClr val="tx1"/>
+                </a:solidFill>
+                <a:effectLst/>
+                <a:latin typeface="+mn-lt"/>
+                <a:ea typeface="+mn-ea"/>
+                <a:cs typeface="+mn-cs"/>
+              </a:rPr>
+              <a:t>to one of these sources, </a:t>
+            </a:r>
+            <a:br>
+              <a:rPr lang="en-US" sz="1200" b="0" i="0" kern="1200" dirty="0">
+                <a:solidFill>
+                  <a:schemeClr val="tx1"/>
+                </a:solidFill>
+                <a:effectLst/>
+                <a:latin typeface="+mn-lt"/>
+                <a:ea typeface="+mn-ea"/>
+                <a:cs typeface="+mn-cs"/>
+              </a:rPr>
+            </a:br>
+            <a:r>
+              <a:rPr lang="en-US" sz="1200" b="0" i="0" kern="1200" dirty="0">
+                <a:solidFill>
+                  <a:schemeClr val="tx1"/>
+                </a:solidFill>
+                <a:effectLst/>
+                <a:latin typeface="+mn-lt"/>
+                <a:ea typeface="+mn-ea"/>
+                <a:cs typeface="+mn-cs"/>
+              </a:rPr>
+              <a:t>so provenance is always visible</a:t>
+            </a:r>
+            <a:endParaRPr dirty="0"/>
           </a:p>
         </p:txBody>
       </p:sp>
@@ -4072,8 +5818,151 @@
           <a:lstStyle/>
           <a:p>
             <a:r>
-              <a:t>Cover the AI stack and safeguards. Keep the distinction clear: retrieval identifies evidence; generation summarizes only what retrieval supports.</a:t>
-            </a:r>
+              <a:rPr lang="en-US" sz="1200" b="0" i="0" kern="1200" dirty="0">
+                <a:solidFill>
+                  <a:schemeClr val="tx1"/>
+                </a:solidFill>
+                <a:effectLst/>
+                <a:latin typeface="+mn-lt"/>
+                <a:ea typeface="+mn-ea"/>
+                <a:cs typeface="+mn-cs"/>
+              </a:rPr>
+              <a:t>The system supports semantic </a:t>
+            </a:r>
+          </a:p>
+          <a:p>
+            <a:r>
+              <a:rPr lang="en-US" sz="1200" b="0" i="0" kern="1200" dirty="0">
+                <a:solidFill>
+                  <a:schemeClr val="tx1"/>
+                </a:solidFill>
+                <a:effectLst/>
+                <a:latin typeface="+mn-lt"/>
+                <a:ea typeface="+mn-ea"/>
+                <a:cs typeface="+mn-cs"/>
+              </a:rPr>
+              <a:t>and keyword search over indexed passages. </a:t>
+            </a:r>
+          </a:p>
+          <a:p>
+            <a:endParaRPr lang="en-US" sz="1200" b="0" i="0" kern="1200" dirty="0">
+              <a:solidFill>
+                <a:schemeClr val="tx1"/>
+              </a:solidFill>
+              <a:effectLst/>
+              <a:latin typeface="+mn-lt"/>
+              <a:ea typeface="+mn-ea"/>
+              <a:cs typeface="+mn-cs"/>
+            </a:endParaRPr>
+          </a:p>
+          <a:p>
+            <a:r>
+              <a:rPr lang="en-US" sz="1200" b="0" i="0" kern="1200" dirty="0">
+                <a:solidFill>
+                  <a:schemeClr val="tx1"/>
+                </a:solidFill>
+                <a:effectLst/>
+                <a:latin typeface="+mn-lt"/>
+                <a:ea typeface="+mn-ea"/>
+                <a:cs typeface="+mn-cs"/>
+              </a:rPr>
+              <a:t>The compare workspace lets researchers </a:t>
+            </a:r>
+            <a:br>
+              <a:rPr lang="en-US" sz="1200" b="0" i="0" kern="1200" dirty="0">
+                <a:solidFill>
+                  <a:schemeClr val="tx1"/>
+                </a:solidFill>
+                <a:effectLst/>
+                <a:latin typeface="+mn-lt"/>
+                <a:ea typeface="+mn-ea"/>
+                <a:cs typeface="+mn-cs"/>
+              </a:rPr>
+            </a:br>
+            <a:r>
+              <a:rPr lang="en-US" sz="1200" b="0" i="0" kern="1200" dirty="0">
+                <a:solidFill>
+                  <a:schemeClr val="tx1"/>
+                </a:solidFill>
+                <a:effectLst/>
+                <a:latin typeface="+mn-lt"/>
+                <a:ea typeface="+mn-ea"/>
+                <a:cs typeface="+mn-cs"/>
+              </a:rPr>
+              <a:t>place studies side by side. </a:t>
+            </a:r>
+          </a:p>
+          <a:p>
+            <a:endParaRPr lang="en-US" sz="1200" b="0" i="0" kern="1200" dirty="0">
+              <a:solidFill>
+                <a:schemeClr val="tx1"/>
+              </a:solidFill>
+              <a:effectLst/>
+              <a:latin typeface="+mn-lt"/>
+              <a:ea typeface="+mn-ea"/>
+              <a:cs typeface="+mn-cs"/>
+            </a:endParaRPr>
+          </a:p>
+          <a:p>
+            <a:r>
+              <a:rPr lang="en-US" sz="1200" b="0" i="0" kern="1200" dirty="0">
+                <a:solidFill>
+                  <a:schemeClr val="tx1"/>
+                </a:solidFill>
+                <a:effectLst/>
+                <a:latin typeface="+mn-lt"/>
+                <a:ea typeface="+mn-ea"/>
+                <a:cs typeface="+mn-cs"/>
+              </a:rPr>
+              <a:t>Comparison is metadata-based </a:t>
+            </a:r>
+            <a:br>
+              <a:rPr lang="en-US" sz="1200" b="0" i="0" kern="1200" dirty="0">
+                <a:solidFill>
+                  <a:schemeClr val="tx1"/>
+                </a:solidFill>
+                <a:effectLst/>
+                <a:latin typeface="+mn-lt"/>
+                <a:ea typeface="+mn-ea"/>
+                <a:cs typeface="+mn-cs"/>
+              </a:rPr>
+            </a:br>
+            <a:r>
+              <a:rPr lang="en-US" sz="1200" b="0" i="0" kern="1200" dirty="0">
+                <a:solidFill>
+                  <a:schemeClr val="tx1"/>
+                </a:solidFill>
+                <a:effectLst/>
+                <a:latin typeface="+mn-lt"/>
+                <a:ea typeface="+mn-ea"/>
+                <a:cs typeface="+mn-cs"/>
+              </a:rPr>
+              <a:t>and deliberately </a:t>
+            </a:r>
+            <a:br>
+              <a:rPr lang="en-US" sz="1200" b="0" i="0" kern="1200" dirty="0">
+                <a:solidFill>
+                  <a:schemeClr val="tx1"/>
+                </a:solidFill>
+                <a:effectLst/>
+                <a:latin typeface="+mn-lt"/>
+                <a:ea typeface="+mn-ea"/>
+                <a:cs typeface="+mn-cs"/>
+              </a:rPr>
+            </a:br>
+            <a:r>
+              <a:rPr lang="en-US" sz="1200" b="0" i="0" kern="1200" dirty="0">
+                <a:solidFill>
+                  <a:schemeClr val="tx1"/>
+                </a:solidFill>
+                <a:effectLst/>
+                <a:latin typeface="+mn-lt"/>
+                <a:ea typeface="+mn-ea"/>
+                <a:cs typeface="+mn-cs"/>
+              </a:rPr>
+              <a:t>does not invent cross-study findings</a:t>
+            </a:r>
+            <a:endParaRPr dirty="0"/>
           </a:p>
         </p:txBody>
       </p:sp>
@@ -4142,8 +6031,194 @@
           <a:lstStyle/>
           <a:p>
             <a:r>
-              <a:t>Summarize measurable engineering results. Avoid claiming scientific accuracy beyond the available evaluation fixtures and human review process.</a:t>
-            </a:r>
+              <a:rPr lang="en-US" sz="1200" b="0" i="0" kern="1200" dirty="0">
+                <a:solidFill>
+                  <a:schemeClr val="tx1"/>
+                </a:solidFill>
+                <a:effectLst/>
+                <a:latin typeface="+mn-lt"/>
+                <a:ea typeface="+mn-ea"/>
+                <a:cs typeface="+mn-cs"/>
+              </a:rPr>
+              <a:t>The AI stack uses local embeddings by default, </a:t>
+            </a:r>
+            <a:br>
+              <a:rPr lang="en-US" sz="1200" b="0" i="0" kern="1200" dirty="0">
+                <a:solidFill>
+                  <a:schemeClr val="tx1"/>
+                </a:solidFill>
+                <a:effectLst/>
+                <a:latin typeface="+mn-lt"/>
+                <a:ea typeface="+mn-ea"/>
+                <a:cs typeface="+mn-cs"/>
+              </a:rPr>
+            </a:br>
+            <a:r>
+              <a:rPr lang="en-US" sz="1200" b="0" i="0" kern="1200" dirty="0">
+                <a:solidFill>
+                  <a:schemeClr val="tx1"/>
+                </a:solidFill>
+                <a:effectLst/>
+                <a:latin typeface="+mn-lt"/>
+                <a:ea typeface="+mn-ea"/>
+                <a:cs typeface="+mn-cs"/>
+              </a:rPr>
+              <a:t>with an optional OpenAI model for generation. </a:t>
+            </a:r>
+          </a:p>
+          <a:p>
+            <a:endParaRPr lang="en-US" sz="1200" b="0" i="0" kern="1200" dirty="0">
+              <a:solidFill>
+                <a:schemeClr val="tx1"/>
+              </a:solidFill>
+              <a:effectLst/>
+              <a:latin typeface="+mn-lt"/>
+              <a:ea typeface="+mn-ea"/>
+              <a:cs typeface="+mn-cs"/>
+            </a:endParaRPr>
+          </a:p>
+          <a:p>
+            <a:r>
+              <a:rPr lang="en-US" sz="1200" b="0" i="0" kern="1200" dirty="0">
+                <a:solidFill>
+                  <a:schemeClr val="tx1"/>
+                </a:solidFill>
+                <a:effectLst/>
+                <a:latin typeface="+mn-lt"/>
+                <a:ea typeface="+mn-ea"/>
+                <a:cs typeface="+mn-cs"/>
+              </a:rPr>
+              <a:t>The key safeguard is the distinction </a:t>
+            </a:r>
+            <a:br>
+              <a:rPr lang="en-US" sz="1200" b="0" i="0" kern="1200" dirty="0">
+                <a:solidFill>
+                  <a:schemeClr val="tx1"/>
+                </a:solidFill>
+                <a:effectLst/>
+                <a:latin typeface="+mn-lt"/>
+                <a:ea typeface="+mn-ea"/>
+                <a:cs typeface="+mn-cs"/>
+              </a:rPr>
+            </a:br>
+            <a:r>
+              <a:rPr lang="en-US" sz="1200" b="0" i="0" kern="1200" dirty="0">
+                <a:solidFill>
+                  <a:schemeClr val="tx1"/>
+                </a:solidFill>
+                <a:effectLst/>
+                <a:latin typeface="+mn-lt"/>
+                <a:ea typeface="+mn-ea"/>
+                <a:cs typeface="+mn-cs"/>
+              </a:rPr>
+              <a:t>between retrieval and generation: </a:t>
+            </a:r>
+            <a:br>
+              <a:rPr lang="en-US" sz="1200" b="0" i="0" kern="1200" dirty="0">
+                <a:solidFill>
+                  <a:schemeClr val="tx1"/>
+                </a:solidFill>
+                <a:effectLst/>
+                <a:latin typeface="+mn-lt"/>
+                <a:ea typeface="+mn-ea"/>
+                <a:cs typeface="+mn-cs"/>
+              </a:rPr>
+            </a:br>
+            <a:endParaRPr lang="en-US" sz="1200" b="0" i="0" kern="1200" dirty="0">
+              <a:solidFill>
+                <a:schemeClr val="tx1"/>
+              </a:solidFill>
+              <a:effectLst/>
+              <a:latin typeface="+mn-lt"/>
+              <a:ea typeface="+mn-ea"/>
+              <a:cs typeface="+mn-cs"/>
+            </a:endParaRPr>
+          </a:p>
+          <a:p>
+            <a:r>
+              <a:rPr lang="en-US" sz="1200" b="0" i="0" kern="1200" dirty="0">
+                <a:solidFill>
+                  <a:schemeClr val="tx1"/>
+                </a:solidFill>
+                <a:effectLst/>
+                <a:latin typeface="+mn-lt"/>
+                <a:ea typeface="+mn-ea"/>
+                <a:cs typeface="+mn-cs"/>
+              </a:rPr>
+              <a:t>retrieval identifies evidence, </a:t>
+            </a:r>
+            <a:br>
+              <a:rPr lang="en-US" sz="1200" b="0" i="0" kern="1200" dirty="0">
+                <a:solidFill>
+                  <a:schemeClr val="tx1"/>
+                </a:solidFill>
+                <a:effectLst/>
+                <a:latin typeface="+mn-lt"/>
+                <a:ea typeface="+mn-ea"/>
+                <a:cs typeface="+mn-cs"/>
+              </a:rPr>
+            </a:br>
+            <a:r>
+              <a:rPr lang="en-US" sz="1200" b="0" i="0" kern="1200" dirty="0">
+                <a:solidFill>
+                  <a:schemeClr val="tx1"/>
+                </a:solidFill>
+                <a:effectLst/>
+                <a:latin typeface="+mn-lt"/>
+                <a:ea typeface="+mn-ea"/>
+                <a:cs typeface="+mn-cs"/>
+              </a:rPr>
+              <a:t>and generation summarizes </a:t>
+            </a:r>
+            <a:br>
+              <a:rPr lang="en-US" sz="1200" b="0" i="0" kern="1200" dirty="0">
+                <a:solidFill>
+                  <a:schemeClr val="tx1"/>
+                </a:solidFill>
+                <a:effectLst/>
+                <a:latin typeface="+mn-lt"/>
+                <a:ea typeface="+mn-ea"/>
+                <a:cs typeface="+mn-cs"/>
+              </a:rPr>
+            </a:br>
+            <a:r>
+              <a:rPr lang="en-US" sz="1200" b="0" i="0" kern="1200" dirty="0">
+                <a:solidFill>
+                  <a:schemeClr val="tx1"/>
+                </a:solidFill>
+                <a:effectLst/>
+                <a:latin typeface="+mn-lt"/>
+                <a:ea typeface="+mn-ea"/>
+                <a:cs typeface="+mn-cs"/>
+              </a:rPr>
+              <a:t>only what retrieval supports. </a:t>
+            </a:r>
+          </a:p>
+          <a:p>
+            <a:endParaRPr lang="en-US" sz="1200" b="0" i="0" kern="1200" dirty="0">
+              <a:solidFill>
+                <a:schemeClr val="tx1"/>
+              </a:solidFill>
+              <a:effectLst/>
+              <a:latin typeface="+mn-lt"/>
+              <a:ea typeface="+mn-ea"/>
+              <a:cs typeface="+mn-cs"/>
+            </a:endParaRPr>
+          </a:p>
+          <a:p>
+            <a:r>
+              <a:rPr lang="en-US" sz="1200" b="0" i="0" kern="1200" dirty="0">
+                <a:solidFill>
+                  <a:schemeClr val="tx1"/>
+                </a:solidFill>
+                <a:effectLst/>
+                <a:latin typeface="+mn-lt"/>
+                <a:ea typeface="+mn-ea"/>
+                <a:cs typeface="+mn-cs"/>
+              </a:rPr>
+              <a:t>Nothing more</a:t>
+            </a:r>
+            <a:endParaRPr dirty="0"/>
           </a:p>
         </p:txBody>
       </p:sp>
@@ -4212,8 +6287,188 @@
           <a:lstStyle/>
           <a:p>
             <a:r>
-              <a:t>Explain the live-demo sequence and backup plan. The student has already notified the program that he will not participate in the live final showcase presentation; these artifacts support evaluation and handoff.</a:t>
-            </a:r>
+              <a:rPr lang="en-US" sz="1200" b="0" i="0" kern="1200" dirty="0">
+                <a:solidFill>
+                  <a:schemeClr val="tx1"/>
+                </a:solidFill>
+                <a:effectLst/>
+                <a:latin typeface="+mn-lt"/>
+                <a:ea typeface="+mn-ea"/>
+                <a:cs typeface="+mn-cs"/>
+              </a:rPr>
+              <a:t>Engineering validation includes linting, </a:t>
+            </a:r>
+          </a:p>
+          <a:p>
+            <a:r>
+              <a:rPr lang="en-US" sz="1200" b="0" i="0" kern="1200" dirty="0">
+                <a:solidFill>
+                  <a:schemeClr val="tx1"/>
+                </a:solidFill>
+                <a:effectLst/>
+                <a:latin typeface="+mn-lt"/>
+                <a:ea typeface="+mn-ea"/>
+                <a:cs typeface="+mn-cs"/>
+              </a:rPr>
+              <a:t>type checking, </a:t>
+            </a:r>
+          </a:p>
+          <a:p>
+            <a:r>
+              <a:rPr lang="en-US" sz="1200" b="0" i="0" kern="1200" dirty="0">
+                <a:solidFill>
+                  <a:schemeClr val="tx1"/>
+                </a:solidFill>
+                <a:effectLst/>
+                <a:latin typeface="+mn-lt"/>
+                <a:ea typeface="+mn-ea"/>
+                <a:cs typeface="+mn-cs"/>
+              </a:rPr>
+              <a:t>unit tests, </a:t>
+            </a:r>
+          </a:p>
+          <a:p>
+            <a:r>
+              <a:rPr lang="en-US" sz="1200" b="0" i="0" kern="1200" dirty="0">
+                <a:solidFill>
+                  <a:schemeClr val="tx1"/>
+                </a:solidFill>
+                <a:effectLst/>
+                <a:latin typeface="+mn-lt"/>
+                <a:ea typeface="+mn-ea"/>
+                <a:cs typeface="+mn-cs"/>
+              </a:rPr>
+              <a:t>web tests, </a:t>
+            </a:r>
+          </a:p>
+          <a:p>
+            <a:r>
+              <a:rPr lang="en-US" sz="1200" b="0" i="0" kern="1200" dirty="0">
+                <a:solidFill>
+                  <a:schemeClr val="tx1"/>
+                </a:solidFill>
+                <a:effectLst/>
+                <a:latin typeface="+mn-lt"/>
+                <a:ea typeface="+mn-ea"/>
+                <a:cs typeface="+mn-cs"/>
+              </a:rPr>
+              <a:t>and a production </a:t>
+            </a:r>
+            <a:r>
+              <a:rPr lang="en-US" sz="1200" b="0" i="0" kern="1200" dirty="0" err="1">
+                <a:solidFill>
+                  <a:schemeClr val="tx1"/>
+                </a:solidFill>
+                <a:effectLst/>
+                <a:latin typeface="+mn-lt"/>
+                <a:ea typeface="+mn-ea"/>
+                <a:cs typeface="+mn-cs"/>
+              </a:rPr>
+              <a:t>Next.js</a:t>
+            </a:r>
+            <a:r>
+              <a:rPr lang="en-US" sz="1200" b="0" i="0" kern="1200" dirty="0">
+                <a:solidFill>
+                  <a:schemeClr val="tx1"/>
+                </a:solidFill>
+                <a:effectLst/>
+                <a:latin typeface="+mn-lt"/>
+                <a:ea typeface="+mn-ea"/>
+                <a:cs typeface="+mn-cs"/>
+              </a:rPr>
+              <a:t> build. </a:t>
+            </a:r>
+          </a:p>
+          <a:p>
+            <a:endParaRPr lang="en-US" sz="1200" b="0" i="0" kern="1200" dirty="0">
+              <a:solidFill>
+                <a:schemeClr val="tx1"/>
+              </a:solidFill>
+              <a:effectLst/>
+              <a:latin typeface="+mn-lt"/>
+              <a:ea typeface="+mn-ea"/>
+              <a:cs typeface="+mn-cs"/>
+            </a:endParaRPr>
+          </a:p>
+          <a:p>
+            <a:r>
+              <a:rPr lang="en-US" sz="1200" b="0" i="0" kern="1200" dirty="0">
+                <a:solidFill>
+                  <a:schemeClr val="tx1"/>
+                </a:solidFill>
+                <a:effectLst/>
+                <a:latin typeface="+mn-lt"/>
+                <a:ea typeface="+mn-ea"/>
+                <a:cs typeface="+mn-cs"/>
+              </a:rPr>
+              <a:t>The app reports measurable engineering results </a:t>
+            </a:r>
+          </a:p>
+          <a:p>
+            <a:r>
+              <a:rPr lang="en-US" sz="1200" b="0" i="0" kern="1200" dirty="0">
+                <a:solidFill>
+                  <a:schemeClr val="tx1"/>
+                </a:solidFill>
+                <a:effectLst/>
+                <a:latin typeface="+mn-lt"/>
+                <a:ea typeface="+mn-ea"/>
+                <a:cs typeface="+mn-cs"/>
+              </a:rPr>
+              <a:t>while avoiding claims of scientific accuracy </a:t>
+            </a:r>
+          </a:p>
+          <a:p>
+            <a:r>
+              <a:rPr lang="en-US" sz="1200" b="0" i="0" kern="1200" dirty="0">
+                <a:solidFill>
+                  <a:schemeClr val="tx1"/>
+                </a:solidFill>
+                <a:effectLst/>
+                <a:latin typeface="+mn-lt"/>
+                <a:ea typeface="+mn-ea"/>
+                <a:cs typeface="+mn-cs"/>
+              </a:rPr>
+              <a:t>beyond </a:t>
+            </a:r>
+            <a:br>
+              <a:rPr lang="en-US" sz="1200" b="0" i="0" kern="1200" dirty="0">
+                <a:solidFill>
+                  <a:schemeClr val="tx1"/>
+                </a:solidFill>
+                <a:effectLst/>
+                <a:latin typeface="+mn-lt"/>
+                <a:ea typeface="+mn-ea"/>
+                <a:cs typeface="+mn-cs"/>
+              </a:rPr>
+            </a:br>
+            <a:r>
+              <a:rPr lang="en-US" sz="1200" b="0" i="0" kern="1200" dirty="0">
+                <a:solidFill>
+                  <a:schemeClr val="tx1"/>
+                </a:solidFill>
+                <a:effectLst/>
+                <a:latin typeface="+mn-lt"/>
+                <a:ea typeface="+mn-ea"/>
+                <a:cs typeface="+mn-cs"/>
+              </a:rPr>
+              <a:t>the available evaluation fixtures </a:t>
+            </a:r>
+          </a:p>
+          <a:p>
+            <a:r>
+              <a:rPr lang="en-US" sz="1200" b="0" i="0" kern="1200" dirty="0">
+                <a:solidFill>
+                  <a:schemeClr val="tx1"/>
+                </a:solidFill>
+                <a:effectLst/>
+                <a:latin typeface="+mn-lt"/>
+                <a:ea typeface="+mn-ea"/>
+                <a:cs typeface="+mn-cs"/>
+              </a:rPr>
+              <a:t>and human review process</a:t>
+            </a:r>
+            <a:endParaRPr dirty="0"/>
           </a:p>
         </p:txBody>
       </p:sp>
@@ -4416,7 +6671,7 @@
           <a:p>
             <a:fld id="{5BCAD085-E8A6-8845-BD4E-CB4CCA059FC4}" type="datetimeFigureOut">
               <a:rPr lang="en-US" smtClean="0"/>
-              <a:t>8/26/26</a:t>
+              <a:t>8/29/26</a:t>
             </a:fld>
             <a:endParaRPr lang="en-US"/>
           </a:p>
@@ -4584,7 +6839,7 @@
           <a:p>
             <a:fld id="{5BCAD085-E8A6-8845-BD4E-CB4CCA059FC4}" type="datetimeFigureOut">
               <a:rPr lang="en-US" smtClean="0"/>
-              <a:t>8/26/26</a:t>
+              <a:t>8/29/26</a:t>
             </a:fld>
             <a:endParaRPr lang="en-US"/>
           </a:p>
@@ -4762,7 +7017,7 @@
           <a:p>
             <a:fld id="{5BCAD085-E8A6-8845-BD4E-CB4CCA059FC4}" type="datetimeFigureOut">
               <a:rPr lang="en-US" smtClean="0"/>
-              <a:t>8/26/26</a:t>
+              <a:t>8/29/26</a:t>
             </a:fld>
             <a:endParaRPr lang="en-US"/>
           </a:p>
@@ -4930,7 +7185,7 @@
           <a:p>
             <a:fld id="{5BCAD085-E8A6-8845-BD4E-CB4CCA059FC4}" type="datetimeFigureOut">
               <a:rPr lang="en-US" smtClean="0"/>
-              <a:t>8/26/26</a:t>
+              <a:t>8/29/26</a:t>
             </a:fld>
             <a:endParaRPr lang="en-US"/>
           </a:p>
@@ -5175,7 +7430,7 @@
           <a:p>
             <a:fld id="{5BCAD085-E8A6-8845-BD4E-CB4CCA059FC4}" type="datetimeFigureOut">
               <a:rPr lang="en-US" smtClean="0"/>
-              <a:t>8/26/26</a:t>
+              <a:t>8/29/26</a:t>
             </a:fld>
             <a:endParaRPr lang="en-US"/>
           </a:p>
@@ -5460,7 +7715,7 @@
           <a:p>
             <a:fld id="{5BCAD085-E8A6-8845-BD4E-CB4CCA059FC4}" type="datetimeFigureOut">
               <a:rPr lang="en-US" smtClean="0"/>
-              <a:t>8/26/26</a:t>
+              <a:t>8/29/26</a:t>
             </a:fld>
             <a:endParaRPr lang="en-US"/>
           </a:p>
@@ -5879,7 +8134,7 @@
           <a:p>
             <a:fld id="{5BCAD085-E8A6-8845-BD4E-CB4CCA059FC4}" type="datetimeFigureOut">
               <a:rPr lang="en-US" smtClean="0"/>
-              <a:t>8/26/26</a:t>
+              <a:t>8/29/26</a:t>
             </a:fld>
             <a:endParaRPr lang="en-US"/>
           </a:p>
@@ -5996,7 +8251,7 @@
           <a:p>
             <a:fld id="{5BCAD085-E8A6-8845-BD4E-CB4CCA059FC4}" type="datetimeFigureOut">
               <a:rPr lang="en-US" smtClean="0"/>
-              <a:t>8/26/26</a:t>
+              <a:t>8/29/26</a:t>
             </a:fld>
             <a:endParaRPr lang="en-US"/>
           </a:p>
@@ -6091,7 +8346,7 @@
           <a:p>
             <a:fld id="{5BCAD085-E8A6-8845-BD4E-CB4CCA059FC4}" type="datetimeFigureOut">
               <a:rPr lang="en-US" smtClean="0"/>
-              <a:t>8/26/26</a:t>
+              <a:t>8/29/26</a:t>
             </a:fld>
             <a:endParaRPr lang="en-US"/>
           </a:p>
@@ -6366,7 +8621,7 @@
           <a:p>
             <a:fld id="{5BCAD085-E8A6-8845-BD4E-CB4CCA059FC4}" type="datetimeFigureOut">
               <a:rPr lang="en-US" smtClean="0"/>
-              <a:t>8/26/26</a:t>
+              <a:t>8/29/26</a:t>
             </a:fld>
             <a:endParaRPr lang="en-US"/>
           </a:p>
@@ -6618,7 +8873,7 @@
           <a:p>
             <a:fld id="{5BCAD085-E8A6-8845-BD4E-CB4CCA059FC4}" type="datetimeFigureOut">
               <a:rPr lang="en-US" smtClean="0"/>
-              <a:t>8/26/26</a:t>
+              <a:t>8/29/26</a:t>
             </a:fld>
             <a:endParaRPr lang="en-US"/>
           </a:p>
@@ -6829,7 +9084,7 @@
           <a:p>
             <a:fld id="{5BCAD085-E8A6-8845-BD4E-CB4CCA059FC4}" type="datetimeFigureOut">
               <a:rPr lang="en-US" smtClean="0"/>
-              <a:t>8/26/26</a:t>
+              <a:t>8/29/26</a:t>
             </a:fld>
             <a:endParaRPr lang="en-US"/>
           </a:p>
@@ -7219,7 +9474,7 @@
           <p:nvPr/>
         </p:nvPicPr>
         <p:blipFill>
-          <a:blip r:embed="rId2"/>
+          <a:blip r:embed="rId3"/>
           <a:stretch>
             <a:fillRect/>
           </a:stretch>
@@ -7249,7 +9504,7 @@
           <p:nvPr/>
         </p:nvPicPr>
         <p:blipFill>
-          <a:blip r:embed="rId3"/>
+          <a:blip r:embed="rId4"/>
           <a:stretch>
             <a:fillRect/>
           </a:stretch>
@@ -7409,6 +9664,18 @@
   <p:clrMapOvr>
     <a:masterClrMapping/>
   </p:clrMapOvr>
+  <mc:AlternateContent xmlns:mc="http://schemas.openxmlformats.org/markup-compatibility/2006" xmlns:p14="http://schemas.microsoft.com/office/powerpoint/2010/main">
+    <mc:Choice Requires="p14">
+      <p:transition spd="med" p14:dur="700" advTm="41566">
+        <p:fade/>
+      </p:transition>
+    </mc:Choice>
+    <mc:Fallback xmlns="">
+      <p:transition spd="med" advTm="41566">
+        <p:fade/>
+      </p:transition>
+    </mc:Fallback>
+  </mc:AlternateContent>
 </p:sld>
 </file>
 
@@ -7763,6 +10030,18 @@
   <p:clrMapOvr>
     <a:masterClrMapping/>
   </p:clrMapOvr>
+  <mc:AlternateContent xmlns:mc="http://schemas.openxmlformats.org/markup-compatibility/2006" xmlns:p14="http://schemas.microsoft.com/office/powerpoint/2010/main">
+    <mc:Choice Requires="p14">
+      <p:transition spd="med" p14:dur="700" advTm="17266">
+        <p:fade/>
+      </p:transition>
+    </mc:Choice>
+    <mc:Fallback xmlns="">
+      <p:transition spd="med" advTm="17266">
+        <p:fade/>
+      </p:transition>
+    </mc:Fallback>
+  </mc:AlternateContent>
 </p:sld>
 </file>
 
@@ -7926,6 +10205,18 @@
   <p:clrMapOvr>
     <a:masterClrMapping/>
   </p:clrMapOvr>
+  <mc:AlternateContent xmlns:mc="http://schemas.openxmlformats.org/markup-compatibility/2006" xmlns:p14="http://schemas.microsoft.com/office/powerpoint/2010/main">
+    <mc:Choice Requires="p14">
+      <p:transition spd="med" p14:dur="700" advTm="19866">
+        <p:fade/>
+      </p:transition>
+    </mc:Choice>
+    <mc:Fallback xmlns="">
+      <p:transition spd="med" advTm="19866">
+        <p:fade/>
+      </p:transition>
+    </mc:Fallback>
+  </mc:AlternateContent>
 </p:sld>
 </file>
 
@@ -7961,7 +10252,7 @@
           <p:nvPr/>
         </p:nvPicPr>
         <p:blipFill>
-          <a:blip r:embed="rId2"/>
+          <a:blip r:embed="rId3"/>
           <a:stretch>
             <a:fillRect/>
           </a:stretch>
@@ -8265,7 +10556,7 @@
           <p:nvPr/>
         </p:nvPicPr>
         <p:blipFill>
-          <a:blip r:embed="rId3"/>
+          <a:blip r:embed="rId4"/>
           <a:stretch>
             <a:fillRect/>
           </a:stretch>
@@ -8290,6 +10581,18 @@
   <p:clrMapOvr>
     <a:masterClrMapping/>
   </p:clrMapOvr>
+  <mc:AlternateContent xmlns:mc="http://schemas.openxmlformats.org/markup-compatibility/2006" xmlns:p14="http://schemas.microsoft.com/office/powerpoint/2010/main">
+    <mc:Choice Requires="p14">
+      <p:transition spd="med" p14:dur="700" advTm="10700">
+        <p:fade/>
+      </p:transition>
+    </mc:Choice>
+    <mc:Fallback xmlns="">
+      <p:transition spd="med" advTm="10700">
+        <p:fade/>
+      </p:transition>
+    </mc:Fallback>
+  </mc:AlternateContent>
 </p:sld>
 </file>
 
@@ -8683,6 +10986,18 @@
   <p:clrMapOvr>
     <a:masterClrMapping/>
   </p:clrMapOvr>
+  <mc:AlternateContent xmlns:mc="http://schemas.openxmlformats.org/markup-compatibility/2006" xmlns:p14="http://schemas.microsoft.com/office/powerpoint/2010/main">
+    <mc:Choice Requires="p14">
+      <p:transition spd="med" p14:dur="700" advTm="20833">
+        <p:fade/>
+      </p:transition>
+    </mc:Choice>
+    <mc:Fallback xmlns="">
+      <p:transition spd="med" advTm="20833">
+        <p:fade/>
+      </p:transition>
+    </mc:Fallback>
+  </mc:AlternateContent>
 </p:sld>
 </file>
 
@@ -9007,6 +11322,18 @@
   <p:clrMapOvr>
     <a:masterClrMapping/>
   </p:clrMapOvr>
+  <mc:AlternateContent xmlns:mc="http://schemas.openxmlformats.org/markup-compatibility/2006" xmlns:p14="http://schemas.microsoft.com/office/powerpoint/2010/main">
+    <mc:Choice Requires="p14">
+      <p:transition spd="med" p14:dur="700" advTm="19433">
+        <p:fade/>
+      </p:transition>
+    </mc:Choice>
+    <mc:Fallback xmlns="">
+      <p:transition spd="med" advTm="19433">
+        <p:fade/>
+      </p:transition>
+    </mc:Fallback>
+  </mc:AlternateContent>
 </p:sld>
 </file>
 
@@ -9782,6 +12109,18 @@
   <p:clrMapOvr>
     <a:masterClrMapping/>
   </p:clrMapOvr>
+  <mc:AlternateContent xmlns:mc="http://schemas.openxmlformats.org/markup-compatibility/2006" xmlns:p14="http://schemas.microsoft.com/office/powerpoint/2010/main">
+    <mc:Choice Requires="p14">
+      <p:transition spd="med" p14:dur="700" advTm="25600">
+        <p:fade/>
+      </p:transition>
+    </mc:Choice>
+    <mc:Fallback xmlns="">
+      <p:transition spd="med" advTm="25600">
+        <p:fade/>
+      </p:transition>
+    </mc:Fallback>
+  </mc:AlternateContent>
 </p:sld>
 </file>
 
@@ -10115,6 +12454,18 @@
   <p:clrMapOvr>
     <a:masterClrMapping/>
   </p:clrMapOvr>
+  <mc:AlternateContent xmlns:mc="http://schemas.openxmlformats.org/markup-compatibility/2006" xmlns:p14="http://schemas.microsoft.com/office/powerpoint/2010/main">
+    <mc:Choice Requires="p14">
+      <p:transition spd="med" p14:dur="700" advTm="18400">
+        <p:fade/>
+      </p:transition>
+    </mc:Choice>
+    <mc:Fallback xmlns="">
+      <p:transition spd="med" advTm="18400">
+        <p:fade/>
+      </p:transition>
+    </mc:Fallback>
+  </mc:AlternateContent>
 </p:sld>
 </file>
 
@@ -10386,6 +12737,18 @@
   <p:clrMapOvr>
     <a:masterClrMapping/>
   </p:clrMapOvr>
+  <mc:AlternateContent xmlns:mc="http://schemas.openxmlformats.org/markup-compatibility/2006" xmlns:p14="http://schemas.microsoft.com/office/powerpoint/2010/main">
+    <mc:Choice Requires="p14">
+      <p:transition spd="med" p14:dur="700" advTm="19283">
+        <p:fade/>
+      </p:transition>
+    </mc:Choice>
+    <mc:Fallback xmlns="">
+      <p:transition spd="med" advTm="19283">
+        <p:fade/>
+      </p:transition>
+    </mc:Fallback>
+  </mc:AlternateContent>
 </p:sld>
 </file>
 
@@ -10682,6 +13045,18 @@
   <p:clrMapOvr>
     <a:masterClrMapping/>
   </p:clrMapOvr>
+  <mc:AlternateContent xmlns:mc="http://schemas.openxmlformats.org/markup-compatibility/2006" xmlns:p14="http://schemas.microsoft.com/office/powerpoint/2010/main">
+    <mc:Choice Requires="p14">
+      <p:transition spd="med" p14:dur="700" advTm="16933">
+        <p:fade/>
+      </p:transition>
+    </mc:Choice>
+    <mc:Fallback xmlns="">
+      <p:transition spd="med" advTm="16933">
+        <p:fade/>
+      </p:transition>
+    </mc:Fallback>
+  </mc:AlternateContent>
 </p:sld>
 </file>
 
@@ -11249,6 +13624,18 @@
   <p:clrMapOvr>
     <a:masterClrMapping/>
   </p:clrMapOvr>
+  <mc:AlternateContent xmlns:mc="http://schemas.openxmlformats.org/markup-compatibility/2006" xmlns:p14="http://schemas.microsoft.com/office/powerpoint/2010/main">
+    <mc:Choice Requires="p14">
+      <p:transition spd="med" p14:dur="700" advTm="19780">
+        <p:fade/>
+      </p:transition>
+    </mc:Choice>
+    <mc:Fallback xmlns="">
+      <p:transition spd="med" advTm="19780">
+        <p:fade/>
+      </p:transition>
+    </mc:Fallback>
+  </mc:AlternateContent>
 </p:sld>
 </file>
 
@@ -11701,6 +14088,18 @@
   <p:clrMapOvr>
     <a:masterClrMapping/>
   </p:clrMapOvr>
+  <mc:AlternateContent xmlns:mc="http://schemas.openxmlformats.org/markup-compatibility/2006" xmlns:p14="http://schemas.microsoft.com/office/powerpoint/2010/main">
+    <mc:Choice Requires="p14">
+      <p:transition spd="med" p14:dur="700" advTm="17700">
+        <p:fade/>
+      </p:transition>
+    </mc:Choice>
+    <mc:Fallback xmlns="">
+      <p:transition spd="med" advTm="17700">
+        <p:fade/>
+      </p:transition>
+    </mc:Fallback>
+  </mc:AlternateContent>
 </p:sld>
 </file>
 

</xml_diff>